<commit_message>
Improve dashboard, audit portability and forecast dispatch comparison
</commit_message>
<xml_diff>
--- a/TEAM-ID-TO-RENAME-AIC-AI能源-GridPulse/02_答辩材料/GridPulse-答辩材料.pptx
+++ b/TEAM-ID-TO-RENAME-AIC-AI能源-GridPulse/02_答辩材料/GridPulse-答辩材料.pptx
@@ -2,27 +2,27 @@
 <file path=ppt/presentation.xml><?xml version="1.0" encoding="utf-8"?>
 <p:presentation xmlns:p="http://schemas.openxmlformats.org/presentationml/2006/main">
   <p:sldMasterIdLst>
-    <p:sldMasterId xmlns:r="http://schemas.openxmlformats.org/officeDocument/2006/relationships" id="2147483648" r:id="R294d5884a4ac453e"/>
+    <p:sldMasterId xmlns:r="http://schemas.openxmlformats.org/officeDocument/2006/relationships" id="2147483648" r:id="R6d53629e9ce641be"/>
   </p:sldMasterIdLst>
   <p:notesMasterIdLst>
-    <p:notesMasterId xmlns:r="http://schemas.openxmlformats.org/officeDocument/2006/relationships" r:id="Rd69eaea44aa54532"/>
+    <p:notesMasterId xmlns:r="http://schemas.openxmlformats.org/officeDocument/2006/relationships" r:id="R6f42d2fb68f04224"/>
   </p:notesMasterIdLst>
   <p:sldIdLst>
-    <p:sldId xmlns:r="http://schemas.openxmlformats.org/officeDocument/2006/relationships" id="256" r:id="R67fd77cf0a2b47d0"/>
-    <p:sldId xmlns:r="http://schemas.openxmlformats.org/officeDocument/2006/relationships" id="257" r:id="Rf570d79920804f72"/>
-    <p:sldId xmlns:r="http://schemas.openxmlformats.org/officeDocument/2006/relationships" id="258" r:id="R622e65efdec2453c"/>
-    <p:sldId xmlns:r="http://schemas.openxmlformats.org/officeDocument/2006/relationships" id="259" r:id="Rc592d2715de14a6f"/>
-    <p:sldId xmlns:r="http://schemas.openxmlformats.org/officeDocument/2006/relationships" id="260" r:id="Rb23850481a5d4e1d"/>
-    <p:sldId xmlns:r="http://schemas.openxmlformats.org/officeDocument/2006/relationships" id="261" r:id="R1575a97c4a894ca4"/>
-    <p:sldId xmlns:r="http://schemas.openxmlformats.org/officeDocument/2006/relationships" id="262" r:id="R6cd4a33370bd419b"/>
-    <p:sldId xmlns:r="http://schemas.openxmlformats.org/officeDocument/2006/relationships" id="263" r:id="Rbb91fb036e09455c"/>
-    <p:sldId xmlns:r="http://schemas.openxmlformats.org/officeDocument/2006/relationships" id="264" r:id="Rce32197040174216"/>
-    <p:sldId xmlns:r="http://schemas.openxmlformats.org/officeDocument/2006/relationships" id="265" r:id="Rf207f3cdd8234093"/>
-    <p:sldId xmlns:r="http://schemas.openxmlformats.org/officeDocument/2006/relationships" id="266" r:id="R446b7083fae2454b"/>
-    <p:sldId xmlns:r="http://schemas.openxmlformats.org/officeDocument/2006/relationships" id="267" r:id="R41ff31313b6a4568"/>
-    <p:sldId xmlns:r="http://schemas.openxmlformats.org/officeDocument/2006/relationships" id="268" r:id="R6d3c376f233a459c"/>
-    <p:sldId xmlns:r="http://schemas.openxmlformats.org/officeDocument/2006/relationships" id="269" r:id="Rb2828e1a3e1e4c9d"/>
-    <p:sldId xmlns:r="http://schemas.openxmlformats.org/officeDocument/2006/relationships" id="270" r:id="R60d3bdb2bb544773"/>
+    <p:sldId xmlns:r="http://schemas.openxmlformats.org/officeDocument/2006/relationships" id="256" r:id="R685d20df711749d6"/>
+    <p:sldId xmlns:r="http://schemas.openxmlformats.org/officeDocument/2006/relationships" id="257" r:id="Re449f9bd5c13469c"/>
+    <p:sldId xmlns:r="http://schemas.openxmlformats.org/officeDocument/2006/relationships" id="258" r:id="Ref7317122a864dc8"/>
+    <p:sldId xmlns:r="http://schemas.openxmlformats.org/officeDocument/2006/relationships" id="259" r:id="R1fb11222734745e1"/>
+    <p:sldId xmlns:r="http://schemas.openxmlformats.org/officeDocument/2006/relationships" id="260" r:id="R594cd14dcc3e422c"/>
+    <p:sldId xmlns:r="http://schemas.openxmlformats.org/officeDocument/2006/relationships" id="261" r:id="Rd4a9f2d8089443ee"/>
+    <p:sldId xmlns:r="http://schemas.openxmlformats.org/officeDocument/2006/relationships" id="262" r:id="R06bf3236da0b484d"/>
+    <p:sldId xmlns:r="http://schemas.openxmlformats.org/officeDocument/2006/relationships" id="263" r:id="R1887e860269443f6"/>
+    <p:sldId xmlns:r="http://schemas.openxmlformats.org/officeDocument/2006/relationships" id="264" r:id="R201b89c3599845b4"/>
+    <p:sldId xmlns:r="http://schemas.openxmlformats.org/officeDocument/2006/relationships" id="265" r:id="Rd1417cf10c484939"/>
+    <p:sldId xmlns:r="http://schemas.openxmlformats.org/officeDocument/2006/relationships" id="266" r:id="R203ede3b0c334504"/>
+    <p:sldId xmlns:r="http://schemas.openxmlformats.org/officeDocument/2006/relationships" id="267" r:id="Redd9c65b08164d5c"/>
+    <p:sldId xmlns:r="http://schemas.openxmlformats.org/officeDocument/2006/relationships" id="268" r:id="R50e6d3315cec4f83"/>
+    <p:sldId xmlns:r="http://schemas.openxmlformats.org/officeDocument/2006/relationships" id="269" r:id="R7334e29d168848a0"/>
+    <p:sldId xmlns:r="http://schemas.openxmlformats.org/officeDocument/2006/relationships" id="270" r:id="Rf3ea6dc6b3cc433f"/>
   </p:sldIdLst>
   <p:sldSz cx="12192000" cy="6858000"/>
   <p:notesSz cx="6858000" cy="9144000"/>
@@ -1483,7 +1483,7 @@
           <p:cNvPr id="3" name="Title">
             <a:extLst xmlns:a="http://schemas.openxmlformats.org/drawingml/2006/main">
               <a:ext uri="{FF2B5EF4-FFF2-40B4-BE49-F238E27FC236}">
-                <a16:creationId xmlns:a16="http://schemas.microsoft.com/office/drawing/2014/main" id="{B8CE2BA4-1A20-4F17-B84C-9AE2DE018A19}"/>
+                <a16:creationId xmlns:a16="http://schemas.microsoft.com/office/drawing/2014/main" id="{14241F40-14EF-489D-8578-B33654DE817F}"/>
               </a:ext>
             </a:extLst>
           </p:cNvPr>
@@ -1640,7 +1640,7 @@
           <p:cNvPr id="2" name="Subtitle">
             <a:extLst xmlns:a="http://schemas.openxmlformats.org/drawingml/2006/main">
               <a:ext uri="{FF2B5EF4-FFF2-40B4-BE49-F238E27FC236}">
-                <a16:creationId xmlns:a16="http://schemas.microsoft.com/office/drawing/2014/main" id="{7D5BCD50-9DF6-4BD2-8C35-C2105214DEFA}"/>
+                <a16:creationId xmlns:a16="http://schemas.microsoft.com/office/drawing/2014/main" id="{9118D0F5-90CA-4692-96CC-6CA0D4F8F16D}"/>
               </a:ext>
             </a:extLst>
           </p:cNvPr>
@@ -1814,7 +1814,7 @@
           <p:cNvPr id="2" name="Section title">
             <a:extLst xmlns:a="http://schemas.openxmlformats.org/drawingml/2006/main">
               <a:ext uri="{FF2B5EF4-FFF2-40B4-BE49-F238E27FC236}">
-                <a16:creationId xmlns:a16="http://schemas.microsoft.com/office/drawing/2014/main" id="{F5C3ADE7-1084-4D03-AEE1-37B8053A5314}"/>
+                <a16:creationId xmlns:a16="http://schemas.microsoft.com/office/drawing/2014/main" id="{B9B02B4B-10AC-477E-A684-6C916088ADC8}"/>
               </a:ext>
             </a:extLst>
           </p:cNvPr>
@@ -1988,7 +1988,7 @@
           <p:cNvPr id="3" name="Title">
             <a:extLst xmlns:a="http://schemas.openxmlformats.org/drawingml/2006/main">
               <a:ext uri="{FF2B5EF4-FFF2-40B4-BE49-F238E27FC236}">
-                <a16:creationId xmlns:a16="http://schemas.microsoft.com/office/drawing/2014/main" id="{0618C609-5E72-4C0C-9BC5-934B03637F5F}"/>
+                <a16:creationId xmlns:a16="http://schemas.microsoft.com/office/drawing/2014/main" id="{F75D1A56-DA10-4577-A218-D1CF9DB13451}"/>
               </a:ext>
             </a:extLst>
           </p:cNvPr>
@@ -2145,7 +2145,7 @@
           <p:cNvPr id="2" name="Body">
             <a:extLst xmlns:a="http://schemas.openxmlformats.org/drawingml/2006/main">
               <a:ext uri="{FF2B5EF4-FFF2-40B4-BE49-F238E27FC236}">
-                <a16:creationId xmlns:a16="http://schemas.microsoft.com/office/drawing/2014/main" id="{AC1C9458-D6D0-4EA8-B256-57D6F366FF6F}"/>
+                <a16:creationId xmlns:a16="http://schemas.microsoft.com/office/drawing/2014/main" id="{E4562834-EBFE-40AC-9383-E508321F60BB}"/>
               </a:ext>
             </a:extLst>
           </p:cNvPr>
@@ -2319,7 +2319,7 @@
           <p:cNvPr id="4" name="Title">
             <a:extLst xmlns:a="http://schemas.openxmlformats.org/drawingml/2006/main">
               <a:ext uri="{FF2B5EF4-FFF2-40B4-BE49-F238E27FC236}">
-                <a16:creationId xmlns:a16="http://schemas.microsoft.com/office/drawing/2014/main" id="{4018AAA3-0B6E-42BF-A4F6-467FA9E18A78}"/>
+                <a16:creationId xmlns:a16="http://schemas.microsoft.com/office/drawing/2014/main" id="{E528B63C-4BCD-48E0-A858-3604A2107137}"/>
               </a:ext>
             </a:extLst>
           </p:cNvPr>
@@ -2476,7 +2476,7 @@
           <p:cNvPr id="2" name="Left column">
             <a:extLst xmlns:a="http://schemas.openxmlformats.org/drawingml/2006/main">
               <a:ext uri="{FF2B5EF4-FFF2-40B4-BE49-F238E27FC236}">
-                <a16:creationId xmlns:a16="http://schemas.microsoft.com/office/drawing/2014/main" id="{01412C17-0FC0-4964-9B08-61C3F39F54CE}"/>
+                <a16:creationId xmlns:a16="http://schemas.microsoft.com/office/drawing/2014/main" id="{F0B541D2-DEC5-42A7-9661-A444FA9A45F7}"/>
               </a:ext>
             </a:extLst>
           </p:cNvPr>
@@ -2633,7 +2633,7 @@
           <p:cNvPr id="3" name="Right column">
             <a:extLst xmlns:a="http://schemas.openxmlformats.org/drawingml/2006/main">
               <a:ext uri="{FF2B5EF4-FFF2-40B4-BE49-F238E27FC236}">
-                <a16:creationId xmlns:a16="http://schemas.microsoft.com/office/drawing/2014/main" id="{FE8F7FC9-1CB6-4107-B1BF-408FFB062698}"/>
+                <a16:creationId xmlns:a16="http://schemas.microsoft.com/office/drawing/2014/main" id="{459AB4C2-D681-422B-AD53-CBF7168704DC}"/>
               </a:ext>
             </a:extLst>
           </p:cNvPr>
@@ -2807,7 +2807,7 @@
           <p:cNvPr id="3" name="Title">
             <a:extLst xmlns:a="http://schemas.openxmlformats.org/drawingml/2006/main">
               <a:ext uri="{FF2B5EF4-FFF2-40B4-BE49-F238E27FC236}">
-                <a16:creationId xmlns:a16="http://schemas.microsoft.com/office/drawing/2014/main" id="{86702871-E216-4760-AA64-90AE81B406FA}"/>
+                <a16:creationId xmlns:a16="http://schemas.microsoft.com/office/drawing/2014/main" id="{D0BFB45F-C934-4A47-8D5E-39620D0EA205}"/>
               </a:ext>
             </a:extLst>
           </p:cNvPr>
@@ -2964,7 +2964,7 @@
           <p:cNvPr id="2" name="Left column">
             <a:extLst xmlns:a="http://schemas.openxmlformats.org/drawingml/2006/main">
               <a:ext uri="{FF2B5EF4-FFF2-40B4-BE49-F238E27FC236}">
-                <a16:creationId xmlns:a16="http://schemas.microsoft.com/office/drawing/2014/main" id="{EF5E09FF-363F-4FBA-955A-4437C6091C95}"/>
+                <a16:creationId xmlns:a16="http://schemas.microsoft.com/office/drawing/2014/main" id="{2C5B4A25-7470-4310-B2DA-C24927EA3BA4}"/>
               </a:ext>
             </a:extLst>
           </p:cNvPr>
@@ -3159,12 +3159,12 @@
   </p:cSld>
   <p:clrMap bg1="lt1" tx1="dk1" bg2="lt2" tx2="dk2" accent1="accent1" accent2="accent2" accent3="accent3" accent4="accent4" accent5="accent5" accent6="accent6" hlink="hlink" folHlink="folHlink"/>
   <p:sldLayoutIdLst>
-    <p:sldLayoutId xmlns:r="http://schemas.openxmlformats.org/officeDocument/2006/relationships" id="2147483649" r:id="Ra76bd44cc1ab4670"/>
-    <p:sldLayoutId xmlns:r="http://schemas.openxmlformats.org/officeDocument/2006/relationships" id="2147483650" r:id="Rb3452e3e2e5d413b"/>
-    <p:sldLayoutId xmlns:r="http://schemas.openxmlformats.org/officeDocument/2006/relationships" id="2147483651" r:id="R598c545dde8a40d6"/>
-    <p:sldLayoutId xmlns:r="http://schemas.openxmlformats.org/officeDocument/2006/relationships" id="2147483652" r:id="R53b4373649454a2d"/>
-    <p:sldLayoutId xmlns:r="http://schemas.openxmlformats.org/officeDocument/2006/relationships" id="2147483653" r:id="R547415b20bb34329"/>
-    <p:sldLayoutId xmlns:r="http://schemas.openxmlformats.org/officeDocument/2006/relationships" id="2147483654" r:id="Rd1a23127525c4858"/>
+    <p:sldLayoutId xmlns:r="http://schemas.openxmlformats.org/officeDocument/2006/relationships" id="2147483649" r:id="Ra8e366cf1e0c4e3a"/>
+    <p:sldLayoutId xmlns:r="http://schemas.openxmlformats.org/officeDocument/2006/relationships" id="2147483650" r:id="R422f37e212014a4f"/>
+    <p:sldLayoutId xmlns:r="http://schemas.openxmlformats.org/officeDocument/2006/relationships" id="2147483651" r:id="Re4e62db9cb9d4777"/>
+    <p:sldLayoutId xmlns:r="http://schemas.openxmlformats.org/officeDocument/2006/relationships" id="2147483652" r:id="R4c471dafe66743db"/>
+    <p:sldLayoutId xmlns:r="http://schemas.openxmlformats.org/officeDocument/2006/relationships" id="2147483653" r:id="Rcc0bbdc1efc346e3"/>
+    <p:sldLayoutId xmlns:r="http://schemas.openxmlformats.org/officeDocument/2006/relationships" id="2147483654" r:id="R927e0dbad0bf4701"/>
   </p:sldLayoutIdLst>
   <p:txStyles>
     <p:titleStyle>
@@ -3711,6 +3711,7 @@
               <a:srgbClr val="0F766E"/>
             </a:solidFill>
           </c:spPr>
+          <c:invertIfNegative val="0"/>
           <c:cat>
             <c:strRef>
               <c:f>'Chart Data'!$A$2:$A$5</c:f>
@@ -3881,6 +3882,7 @@
               <a:srgbClr val="E7A73B"/>
             </a:solidFill>
           </c:spPr>
+          <c:invertIfNegative val="0"/>
           <c:cat>
             <c:strRef>
               <c:f>'Chart Data'!$A$2:$A$5</c:f>
@@ -4055,7 +4057,7 @@
           <p:cNvPr id="8" name="">
             <a:extLst xmlns:a="http://schemas.openxmlformats.org/drawingml/2006/main">
               <a:ext uri="{FF2B5EF4-FFF2-40B4-BE49-F238E27FC236}">
-                <a16:creationId xmlns:a16="http://schemas.microsoft.com/office/drawing/2014/main" id="{3DAB811B-B69D-4C66-B95E-9F8B38362DA6}"/>
+                <a16:creationId xmlns:a16="http://schemas.microsoft.com/office/drawing/2014/main" id="{7A9467A6-EE57-4ADF-AE1C-409D08050B1E}"/>
               </a:ext>
             </a:extLst>
           </p:cNvPr>
@@ -4085,7 +4087,7 @@
           <p:cNvPr id="2" name="">
             <a:extLst xmlns:a="http://schemas.openxmlformats.org/drawingml/2006/main">
               <a:ext uri="{FF2B5EF4-FFF2-40B4-BE49-F238E27FC236}">
-                <a16:creationId xmlns:a16="http://schemas.microsoft.com/office/drawing/2014/main" id="{FC9E0EB9-C6CE-4FF6-A5DF-C2A7820117F0}"/>
+                <a16:creationId xmlns:a16="http://schemas.microsoft.com/office/drawing/2014/main" id="{17F0DCEE-EEA7-4A3F-A8BC-4E243994A312}"/>
               </a:ext>
             </a:extLst>
           </p:cNvPr>
@@ -4115,7 +4117,7 @@
           <p:cNvPr id="3" name="">
             <a:extLst xmlns:a="http://schemas.openxmlformats.org/drawingml/2006/main">
               <a:ext uri="{FF2B5EF4-FFF2-40B4-BE49-F238E27FC236}">
-                <a16:creationId xmlns:a16="http://schemas.microsoft.com/office/drawing/2014/main" id="{6166E122-2D79-4FA4-9EDD-3829D58ACDBF}"/>
+                <a16:creationId xmlns:a16="http://schemas.microsoft.com/office/drawing/2014/main" id="{D51C0424-2455-4376-A4D1-AFF9EF565C04}"/>
               </a:ext>
             </a:extLst>
           </p:cNvPr>
@@ -4183,7 +4185,7 @@
           <p:cNvPr id="4" name="">
             <a:extLst xmlns:a="http://schemas.openxmlformats.org/drawingml/2006/main">
               <a:ext uri="{FF2B5EF4-FFF2-40B4-BE49-F238E27FC236}">
-                <a16:creationId xmlns:a16="http://schemas.microsoft.com/office/drawing/2014/main" id="{85BBD0E0-501C-41B3-862E-56502AC22D8D}"/>
+                <a16:creationId xmlns:a16="http://schemas.microsoft.com/office/drawing/2014/main" id="{3072C510-102E-408D-A864-96656B748552}"/>
               </a:ext>
             </a:extLst>
           </p:cNvPr>
@@ -4251,7 +4253,7 @@
           <p:cNvPr id="5" name="">
             <a:extLst xmlns:a="http://schemas.openxmlformats.org/drawingml/2006/main">
               <a:ext uri="{FF2B5EF4-FFF2-40B4-BE49-F238E27FC236}">
-                <a16:creationId xmlns:a16="http://schemas.microsoft.com/office/drawing/2014/main" id="{882223E3-7DE5-40D3-9111-2D0AD019EE65}"/>
+                <a16:creationId xmlns:a16="http://schemas.microsoft.com/office/drawing/2014/main" id="{CDC0F35C-767D-41EE-8CAE-79965B2A3715}"/>
               </a:ext>
             </a:extLst>
           </p:cNvPr>
@@ -4319,7 +4321,7 @@
           <p:cNvPr id="6" name="">
             <a:extLst xmlns:a="http://schemas.openxmlformats.org/drawingml/2006/main">
               <a:ext uri="{FF2B5EF4-FFF2-40B4-BE49-F238E27FC236}">
-                <a16:creationId xmlns:a16="http://schemas.microsoft.com/office/drawing/2014/main" id="{801AECBD-5112-49C8-8A46-975DAA85B187}"/>
+                <a16:creationId xmlns:a16="http://schemas.microsoft.com/office/drawing/2014/main" id="{79FF13EC-7892-4B87-873A-E965CAC541BB}"/>
               </a:ext>
             </a:extLst>
           </p:cNvPr>
@@ -4387,7 +4389,7 @@
           <p:cNvPr id="7" name="">
             <a:extLst xmlns:a="http://schemas.openxmlformats.org/drawingml/2006/main">
               <a:ext uri="{FF2B5EF4-FFF2-40B4-BE49-F238E27FC236}">
-                <a16:creationId xmlns:a16="http://schemas.microsoft.com/office/drawing/2014/main" id="{34F6AA8B-E784-4278-8071-0CAB61726CB7}"/>
+                <a16:creationId xmlns:a16="http://schemas.microsoft.com/office/drawing/2014/main" id="{DE64827B-F257-4D61-80D9-EAC0FC5BDCB0}"/>
               </a:ext>
             </a:extLst>
           </p:cNvPr>
@@ -4397,7 +4399,7 @@
           <p:nvPr/>
         </p:nvPicPr>
         <p:blipFill>
-          <a:blip xmlns:r="http://schemas.openxmlformats.org/officeDocument/2006/relationships" xmlns:a="http://schemas.openxmlformats.org/drawingml/2006/main" r:embed="R06c625bc68f6466a"/>
+          <a:blip xmlns:r="http://schemas.openxmlformats.org/officeDocument/2006/relationships" xmlns:a="http://schemas.openxmlformats.org/drawingml/2006/main" r:embed="R66b3cdac163a40d1"/>
           <a:stretch xmlns:a="http://schemas.openxmlformats.org/drawingml/2006/main"/>
         </p:blipFill>
         <p:spPr>
@@ -4413,7 +4415,7 @@
     </p:spTree>
     <p:extLst>
       <p:ext uri="{BB962C8B-B14F-4D97-AF65-F5344CB8AC3E}">
-        <p14:creationId xmlns:p14="http://schemas.microsoft.com/office/powerpoint/2010/main" val="1418867253"/>
+        <p14:creationId xmlns:p14="http://schemas.microsoft.com/office/powerpoint/2010/main" val="162885074"/>
       </p:ext>
     </p:extLst>
   </p:cSld>
@@ -4444,7 +4446,7 @@
           <p:cNvPr id="9" name="">
             <a:extLst xmlns:a="http://schemas.openxmlformats.org/drawingml/2006/main">
               <a:ext uri="{FF2B5EF4-FFF2-40B4-BE49-F238E27FC236}">
-                <a16:creationId xmlns:a16="http://schemas.microsoft.com/office/drawing/2014/main" id="{79F7147A-AB15-4939-9F86-0467CC3E92E0}"/>
+                <a16:creationId xmlns:a16="http://schemas.microsoft.com/office/drawing/2014/main" id="{36A3C916-439E-473A-9008-4506C4AA3DEF}"/>
               </a:ext>
             </a:extLst>
           </p:cNvPr>
@@ -4512,7 +4514,7 @@
           <p:cNvPr id="2" name="">
             <a:extLst xmlns:a="http://schemas.openxmlformats.org/drawingml/2006/main">
               <a:ext uri="{FF2B5EF4-FFF2-40B4-BE49-F238E27FC236}">
-                <a16:creationId xmlns:a16="http://schemas.microsoft.com/office/drawing/2014/main" id="{FE78D4D9-91B6-45C6-B917-CEFCB1F272F9}"/>
+                <a16:creationId xmlns:a16="http://schemas.microsoft.com/office/drawing/2014/main" id="{44E99737-3D97-4184-A5DA-BC9687E36B44}"/>
               </a:ext>
             </a:extLst>
           </p:cNvPr>
@@ -4580,7 +4582,7 @@
           <p:cNvPr id="3" name="">
             <a:extLst xmlns:a="http://schemas.openxmlformats.org/drawingml/2006/main">
               <a:ext uri="{FF2B5EF4-FFF2-40B4-BE49-F238E27FC236}">
-                <a16:creationId xmlns:a16="http://schemas.microsoft.com/office/drawing/2014/main" id="{BAA2B2E9-5EE2-4348-8B9E-E078F9D2A9BC}"/>
+                <a16:creationId xmlns:a16="http://schemas.microsoft.com/office/drawing/2014/main" id="{4E387506-A2DF-4AB9-BF9C-84ACAE1C05AF}"/>
               </a:ext>
             </a:extLst>
           </p:cNvPr>
@@ -4610,7 +4612,7 @@
           <p:cNvPr id="4" name="">
             <a:extLst xmlns:a="http://schemas.openxmlformats.org/drawingml/2006/main">
               <a:ext uri="{FF2B5EF4-FFF2-40B4-BE49-F238E27FC236}">
-                <a16:creationId xmlns:a16="http://schemas.microsoft.com/office/drawing/2014/main" id="{BA51D407-EB12-48B0-989F-08E632EA316F}"/>
+                <a16:creationId xmlns:a16="http://schemas.microsoft.com/office/drawing/2014/main" id="{B787FE38-A8F7-4403-8E32-69452C0F864F}"/>
               </a:ext>
             </a:extLst>
           </p:cNvPr>
@@ -5148,7 +5150,7 @@
           <p:cNvPr id="5" name="">
             <a:extLst xmlns:a="http://schemas.openxmlformats.org/drawingml/2006/main">
               <a:ext uri="{FF2B5EF4-FFF2-40B4-BE49-F238E27FC236}">
-                <a16:creationId xmlns:a16="http://schemas.microsoft.com/office/drawing/2014/main" id="{98078C22-3C29-4D22-994E-93FB399E7E25}"/>
+                <a16:creationId xmlns:a16="http://schemas.microsoft.com/office/drawing/2014/main" id="{4E6626C9-FEF9-4856-A272-30A7236BF5BD}"/>
               </a:ext>
             </a:extLst>
           </p:cNvPr>
@@ -5216,7 +5218,7 @@
           <p:cNvPr id="6" name="">
             <a:extLst xmlns:a="http://schemas.openxmlformats.org/drawingml/2006/main">
               <a:ext uri="{FF2B5EF4-FFF2-40B4-BE49-F238E27FC236}">
-                <a16:creationId xmlns:a16="http://schemas.microsoft.com/office/drawing/2014/main" id="{4804AF3D-4A23-473F-82E9-412A326C86CE}"/>
+                <a16:creationId xmlns:a16="http://schemas.microsoft.com/office/drawing/2014/main" id="{81FCED6C-1DCB-4B48-9D2D-EE269EF89FD4}"/>
               </a:ext>
             </a:extLst>
           </p:cNvPr>
@@ -5307,7 +5309,7 @@
           <p:cNvPr id="7" name="">
             <a:extLst xmlns:a="http://schemas.openxmlformats.org/drawingml/2006/main">
               <a:ext uri="{FF2B5EF4-FFF2-40B4-BE49-F238E27FC236}">
-                <a16:creationId xmlns:a16="http://schemas.microsoft.com/office/drawing/2014/main" id="{E3448E0C-9352-4282-9A0A-2791EF51F256}"/>
+                <a16:creationId xmlns:a16="http://schemas.microsoft.com/office/drawing/2014/main" id="{BCE16435-856C-4A13-8CB7-A9A9A5C9ABB1}"/>
               </a:ext>
             </a:extLst>
           </p:cNvPr>
@@ -5398,7 +5400,7 @@
           <p:cNvPr id="8" name="">
             <a:extLst xmlns:a="http://schemas.openxmlformats.org/drawingml/2006/main">
               <a:ext uri="{FF2B5EF4-FFF2-40B4-BE49-F238E27FC236}">
-                <a16:creationId xmlns:a16="http://schemas.microsoft.com/office/drawing/2014/main" id="{B5ED00A7-3422-4C38-AB5C-BF35B0EB5B74}"/>
+                <a16:creationId xmlns:a16="http://schemas.microsoft.com/office/drawing/2014/main" id="{A7161EC8-CBAB-4B11-A251-75C04163EEF6}"/>
               </a:ext>
             </a:extLst>
           </p:cNvPr>
@@ -5464,7 +5466,7 @@
     </p:spTree>
     <p:extLst>
       <p:ext uri="{BB962C8B-B14F-4D97-AF65-F5344CB8AC3E}">
-        <p14:creationId xmlns:p14="http://schemas.microsoft.com/office/powerpoint/2010/main" val="2065108404"/>
+        <p14:creationId xmlns:p14="http://schemas.microsoft.com/office/powerpoint/2010/main" val="1237737997"/>
       </p:ext>
     </p:extLst>
   </p:cSld>
@@ -5495,7 +5497,7 @@
           <p:cNvPr id="9" name="">
             <a:extLst xmlns:a="http://schemas.openxmlformats.org/drawingml/2006/main">
               <a:ext uri="{FF2B5EF4-FFF2-40B4-BE49-F238E27FC236}">
-                <a16:creationId xmlns:a16="http://schemas.microsoft.com/office/drawing/2014/main" id="{4D186041-E403-4BAE-9273-A55F3ECE47E1}"/>
+                <a16:creationId xmlns:a16="http://schemas.microsoft.com/office/drawing/2014/main" id="{3317A401-25FD-4A17-85F4-4B673E7B23F1}"/>
               </a:ext>
             </a:extLst>
           </p:cNvPr>
@@ -5563,7 +5565,7 @@
           <p:cNvPr id="2" name="">
             <a:extLst xmlns:a="http://schemas.openxmlformats.org/drawingml/2006/main">
               <a:ext uri="{FF2B5EF4-FFF2-40B4-BE49-F238E27FC236}">
-                <a16:creationId xmlns:a16="http://schemas.microsoft.com/office/drawing/2014/main" id="{1DAE9C0E-0D50-42DE-B5F5-CB4962E0D316}"/>
+                <a16:creationId xmlns:a16="http://schemas.microsoft.com/office/drawing/2014/main" id="{1EEE7D24-DCE4-40A4-8C0D-040F0A05C913}"/>
               </a:ext>
             </a:extLst>
           </p:cNvPr>
@@ -5631,7 +5633,7 @@
           <p:cNvPr id="3" name="">
             <a:extLst xmlns:a="http://schemas.openxmlformats.org/drawingml/2006/main">
               <a:ext uri="{FF2B5EF4-FFF2-40B4-BE49-F238E27FC236}">
-                <a16:creationId xmlns:a16="http://schemas.microsoft.com/office/drawing/2014/main" id="{F032C3D0-9FA2-4769-AFF4-8440CC2DB647}"/>
+                <a16:creationId xmlns:a16="http://schemas.microsoft.com/office/drawing/2014/main" id="{122F5D93-6634-4934-83CB-9D7CCF513297}"/>
               </a:ext>
             </a:extLst>
           </p:cNvPr>
@@ -5661,7 +5663,7 @@
           <p:cNvPr id="4" name="">
             <a:extLst xmlns:a="http://schemas.openxmlformats.org/drawingml/2006/main">
               <a:ext uri="{FF2B5EF4-FFF2-40B4-BE49-F238E27FC236}">
-                <a16:creationId xmlns:a16="http://schemas.microsoft.com/office/drawing/2014/main" id="{EDFABD11-FBEA-4E32-9710-C012E3CCA4A5}"/>
+                <a16:creationId xmlns:a16="http://schemas.microsoft.com/office/drawing/2014/main" id="{93C1B6C4-456C-47BD-8131-35018DF85160}"/>
               </a:ext>
             </a:extLst>
           </p:cNvPr>
@@ -6281,7 +6283,7 @@
           <p:cNvPr id="5" name="">
             <a:extLst xmlns:a="http://schemas.openxmlformats.org/drawingml/2006/main">
               <a:ext uri="{FF2B5EF4-FFF2-40B4-BE49-F238E27FC236}">
-                <a16:creationId xmlns:a16="http://schemas.microsoft.com/office/drawing/2014/main" id="{29699682-8B2A-4372-A27D-E171F51BF6D3}"/>
+                <a16:creationId xmlns:a16="http://schemas.microsoft.com/office/drawing/2014/main" id="{DA64DE7E-4CC1-483A-B1A6-E6BDE57B00E8}"/>
               </a:ext>
             </a:extLst>
           </p:cNvPr>
@@ -6349,7 +6351,7 @@
           <p:cNvPr id="6" name="">
             <a:extLst xmlns:a="http://schemas.openxmlformats.org/drawingml/2006/main">
               <a:ext uri="{FF2B5EF4-FFF2-40B4-BE49-F238E27FC236}">
-                <a16:creationId xmlns:a16="http://schemas.microsoft.com/office/drawing/2014/main" id="{DE183D9E-D40D-41DB-A585-8D6111CC3DAE}"/>
+                <a16:creationId xmlns:a16="http://schemas.microsoft.com/office/drawing/2014/main" id="{3E8809B8-9492-4E67-B55E-D1DCD34506F4}"/>
               </a:ext>
             </a:extLst>
           </p:cNvPr>
@@ -6440,7 +6442,7 @@
           <p:cNvPr id="7" name="">
             <a:extLst xmlns:a="http://schemas.openxmlformats.org/drawingml/2006/main">
               <a:ext uri="{FF2B5EF4-FFF2-40B4-BE49-F238E27FC236}">
-                <a16:creationId xmlns:a16="http://schemas.microsoft.com/office/drawing/2014/main" id="{12AE45EF-9A2B-4B85-A354-3BC80AE63A0F}"/>
+                <a16:creationId xmlns:a16="http://schemas.microsoft.com/office/drawing/2014/main" id="{B0DE71F4-18C4-4722-A305-33EC8A3A11A2}"/>
               </a:ext>
             </a:extLst>
           </p:cNvPr>
@@ -6531,7 +6533,7 @@
           <p:cNvPr id="8" name="">
             <a:extLst xmlns:a="http://schemas.openxmlformats.org/drawingml/2006/main">
               <a:ext uri="{FF2B5EF4-FFF2-40B4-BE49-F238E27FC236}">
-                <a16:creationId xmlns:a16="http://schemas.microsoft.com/office/drawing/2014/main" id="{E0D023F7-C1D3-4B20-826F-83BB1DD3C5FF}"/>
+                <a16:creationId xmlns:a16="http://schemas.microsoft.com/office/drawing/2014/main" id="{0F8CA6BD-38BF-4447-8207-02AACBAC643F}"/>
               </a:ext>
             </a:extLst>
           </p:cNvPr>
@@ -6597,7 +6599,7 @@
     </p:spTree>
     <p:extLst>
       <p:ext uri="{BB962C8B-B14F-4D97-AF65-F5344CB8AC3E}">
-        <p14:creationId xmlns:p14="http://schemas.microsoft.com/office/powerpoint/2010/main" val="1678011482"/>
+        <p14:creationId xmlns:p14="http://schemas.microsoft.com/office/powerpoint/2010/main" val="1736179360"/>
       </p:ext>
     </p:extLst>
   </p:cSld>
@@ -6628,7 +6630,7 @@
           <p:cNvPr id="10" name="">
             <a:extLst xmlns:a="http://schemas.openxmlformats.org/drawingml/2006/main">
               <a:ext uri="{FF2B5EF4-FFF2-40B4-BE49-F238E27FC236}">
-                <a16:creationId xmlns:a16="http://schemas.microsoft.com/office/drawing/2014/main" id="{4EF30FF8-58C9-40E0-BF74-0CEB52F64A80}"/>
+                <a16:creationId xmlns:a16="http://schemas.microsoft.com/office/drawing/2014/main" id="{332FFBEC-3685-4939-9282-3DE844AD3B85}"/>
               </a:ext>
             </a:extLst>
           </p:cNvPr>
@@ -6696,7 +6698,7 @@
           <p:cNvPr id="2" name="">
             <a:extLst xmlns:a="http://schemas.openxmlformats.org/drawingml/2006/main">
               <a:ext uri="{FF2B5EF4-FFF2-40B4-BE49-F238E27FC236}">
-                <a16:creationId xmlns:a16="http://schemas.microsoft.com/office/drawing/2014/main" id="{C39421E1-FFB6-4ED3-89EF-A664F6087EAB}"/>
+                <a16:creationId xmlns:a16="http://schemas.microsoft.com/office/drawing/2014/main" id="{C5FB3E13-49E5-4A4E-B77E-4B3B60A39C72}"/>
               </a:ext>
             </a:extLst>
           </p:cNvPr>
@@ -6764,7 +6766,7 @@
           <p:cNvPr id="3" name="">
             <a:extLst xmlns:a="http://schemas.openxmlformats.org/drawingml/2006/main">
               <a:ext uri="{FF2B5EF4-FFF2-40B4-BE49-F238E27FC236}">
-                <a16:creationId xmlns:a16="http://schemas.microsoft.com/office/drawing/2014/main" id="{4ECD5F37-DB05-4CB8-B640-71768F9C1C38}"/>
+                <a16:creationId xmlns:a16="http://schemas.microsoft.com/office/drawing/2014/main" id="{DB92C8BF-C124-4D2B-AF58-DAC50BA49723}"/>
               </a:ext>
             </a:extLst>
           </p:cNvPr>
@@ -6794,7 +6796,7 @@
           <p:cNvPr id="4" name="">
             <a:extLst xmlns:a="http://schemas.openxmlformats.org/drawingml/2006/main">
               <a:ext uri="{FF2B5EF4-FFF2-40B4-BE49-F238E27FC236}">
-                <a16:creationId xmlns:a16="http://schemas.microsoft.com/office/drawing/2014/main" id="{0574FDE5-9832-49A6-86E9-B051AB9A3F1B}"/>
+                <a16:creationId xmlns:a16="http://schemas.microsoft.com/office/drawing/2014/main" id="{16F40812-7718-4491-91E7-2147BF9C3450}"/>
               </a:ext>
             </a:extLst>
           </p:cNvPr>
@@ -6862,7 +6864,7 @@
           <p:cNvPr id="5" name="">
             <a:extLst xmlns:a="http://schemas.openxmlformats.org/drawingml/2006/main">
               <a:ext uri="{FF2B5EF4-FFF2-40B4-BE49-F238E27FC236}">
-                <a16:creationId xmlns:a16="http://schemas.microsoft.com/office/drawing/2014/main" id="{9E5CF8AD-7E89-46ED-8D0D-DE0C30B0BF65}"/>
+                <a16:creationId xmlns:a16="http://schemas.microsoft.com/office/drawing/2014/main" id="{E1D11521-F42F-4EE3-AA8F-50061CFD41F7}"/>
               </a:ext>
             </a:extLst>
           </p:cNvPr>
@@ -7154,7 +7156,7 @@
           <p:cNvPr id="6" name="">
             <a:extLst xmlns:a="http://schemas.openxmlformats.org/drawingml/2006/main">
               <a:ext uri="{FF2B5EF4-FFF2-40B4-BE49-F238E27FC236}">
-                <a16:creationId xmlns:a16="http://schemas.microsoft.com/office/drawing/2014/main" id="{EC5B1964-AE71-4A2A-9604-D0AEC40BB73F}"/>
+                <a16:creationId xmlns:a16="http://schemas.microsoft.com/office/drawing/2014/main" id="{1271A4D9-79F7-4DCA-884D-B9FD30D7C231}"/>
               </a:ext>
             </a:extLst>
           </p:cNvPr>
@@ -7222,7 +7224,7 @@
           <p:cNvPr id="7" name="">
             <a:extLst xmlns:a="http://schemas.openxmlformats.org/drawingml/2006/main">
               <a:ext uri="{FF2B5EF4-FFF2-40B4-BE49-F238E27FC236}">
-                <a16:creationId xmlns:a16="http://schemas.microsoft.com/office/drawing/2014/main" id="{0841A057-34E2-4FE9-AF06-D5FAF6A2A44D}"/>
+                <a16:creationId xmlns:a16="http://schemas.microsoft.com/office/drawing/2014/main" id="{A586EED7-3661-4C03-ADC0-6A778E0029DD}"/>
               </a:ext>
             </a:extLst>
           </p:cNvPr>
@@ -7303,7 +7305,7 @@
                 <a:ea typeface="Microsoft YaHei"/>
                 <a:cs typeface="Microsoft YaHei"/>
               </a:rPr>
-              <a:t>原固定策略也达到相同最高点，数学证书不证明动态储备独有优势。</a:t>
+              <a:t>新固定策略也达到相同最高点，数学证书不证明动态储备独有优势。</a:t>
             </a:r>
           </a:p>
         </p:txBody>
@@ -7313,7 +7315,7 @@
           <p:cNvPr id="8" name="">
             <a:extLst xmlns:a="http://schemas.openxmlformats.org/drawingml/2006/main">
               <a:ext uri="{FF2B5EF4-FFF2-40B4-BE49-F238E27FC236}">
-                <a16:creationId xmlns:a16="http://schemas.microsoft.com/office/drawing/2014/main" id="{228923F4-EE70-441C-91AC-E7F9C544A635}"/>
+                <a16:creationId xmlns:a16="http://schemas.microsoft.com/office/drawing/2014/main" id="{3598F9FA-C591-4065-9D4A-EAD42EB27A93}"/>
               </a:ext>
             </a:extLst>
           </p:cNvPr>
@@ -7381,7 +7383,7 @@
           <p:cNvPr id="9" name="">
             <a:extLst xmlns:a="http://schemas.openxmlformats.org/drawingml/2006/main">
               <a:ext uri="{FF2B5EF4-FFF2-40B4-BE49-F238E27FC236}">
-                <a16:creationId xmlns:a16="http://schemas.microsoft.com/office/drawing/2014/main" id="{61E1B3C8-35E3-4E3E-85F7-D6866814F1FE}"/>
+                <a16:creationId xmlns:a16="http://schemas.microsoft.com/office/drawing/2014/main" id="{A36406CA-CC09-4A62-BE41-B7FE7EA77E66}"/>
               </a:ext>
             </a:extLst>
           </p:cNvPr>
@@ -7447,7 +7449,7 @@
     </p:spTree>
     <p:extLst>
       <p:ext uri="{BB962C8B-B14F-4D97-AF65-F5344CB8AC3E}">
-        <p14:creationId xmlns:p14="http://schemas.microsoft.com/office/powerpoint/2010/main" val="245942307"/>
+        <p14:creationId xmlns:p14="http://schemas.microsoft.com/office/powerpoint/2010/main" val="1342033089"/>
       </p:ext>
     </p:extLst>
   </p:cSld>
@@ -7478,7 +7480,7 @@
           <p:cNvPr id="9" name="">
             <a:extLst xmlns:a="http://schemas.openxmlformats.org/drawingml/2006/main">
               <a:ext uri="{FF2B5EF4-FFF2-40B4-BE49-F238E27FC236}">
-                <a16:creationId xmlns:a16="http://schemas.microsoft.com/office/drawing/2014/main" id="{372216CB-CE25-41B7-9429-481F6FA5BAE7}"/>
+                <a16:creationId xmlns:a16="http://schemas.microsoft.com/office/drawing/2014/main" id="{CFAF4B06-7D2E-451F-B25F-11BE940E0D6D}"/>
               </a:ext>
             </a:extLst>
           </p:cNvPr>
@@ -7546,7 +7548,7 @@
           <p:cNvPr id="2" name="">
             <a:extLst xmlns:a="http://schemas.openxmlformats.org/drawingml/2006/main">
               <a:ext uri="{FF2B5EF4-FFF2-40B4-BE49-F238E27FC236}">
-                <a16:creationId xmlns:a16="http://schemas.microsoft.com/office/drawing/2014/main" id="{5EBA6AF6-E1E8-4386-8A78-0514B72FA17A}"/>
+                <a16:creationId xmlns:a16="http://schemas.microsoft.com/office/drawing/2014/main" id="{E87ECD31-9F55-43FB-8629-5876C835DD8E}"/>
               </a:ext>
             </a:extLst>
           </p:cNvPr>
@@ -7614,7 +7616,7 @@
           <p:cNvPr id="3" name="">
             <a:extLst xmlns:a="http://schemas.openxmlformats.org/drawingml/2006/main">
               <a:ext uri="{FF2B5EF4-FFF2-40B4-BE49-F238E27FC236}">
-                <a16:creationId xmlns:a16="http://schemas.microsoft.com/office/drawing/2014/main" id="{7E0F43B4-7073-4EA0-B26A-3FB08C2E9F78}"/>
+                <a16:creationId xmlns:a16="http://schemas.microsoft.com/office/drawing/2014/main" id="{8B001D86-2BE4-4F31-BBAF-431D27C8E950}"/>
               </a:ext>
             </a:extLst>
           </p:cNvPr>
@@ -7644,7 +7646,7 @@
           <p:cNvPr id="4" name="">
             <a:extLst xmlns:a="http://schemas.openxmlformats.org/drawingml/2006/main">
               <a:ext uri="{FF2B5EF4-FFF2-40B4-BE49-F238E27FC236}">
-                <a16:creationId xmlns:a16="http://schemas.microsoft.com/office/drawing/2014/main" id="{3686568F-A00D-4F2C-A0F4-82C18513CE88}"/>
+                <a16:creationId xmlns:a16="http://schemas.microsoft.com/office/drawing/2014/main" id="{BDDBF94F-ADED-46CD-AFCB-CE64F52F818C}"/>
               </a:ext>
             </a:extLst>
           </p:cNvPr>
@@ -8100,7 +8102,7 @@
           <p:cNvPr id="5" name="">
             <a:extLst xmlns:a="http://schemas.openxmlformats.org/drawingml/2006/main">
               <a:ext uri="{FF2B5EF4-FFF2-40B4-BE49-F238E27FC236}">
-                <a16:creationId xmlns:a16="http://schemas.microsoft.com/office/drawing/2014/main" id="{A60D3E98-095A-485C-AFDE-D462DE2D5318}"/>
+                <a16:creationId xmlns:a16="http://schemas.microsoft.com/office/drawing/2014/main" id="{B014E930-0474-42D7-AC7C-2F2725E7894E}"/>
               </a:ext>
             </a:extLst>
           </p:cNvPr>
@@ -8168,7 +8170,7 @@
           <p:cNvPr id="6" name="">
             <a:extLst xmlns:a="http://schemas.openxmlformats.org/drawingml/2006/main">
               <a:ext uri="{FF2B5EF4-FFF2-40B4-BE49-F238E27FC236}">
-                <a16:creationId xmlns:a16="http://schemas.microsoft.com/office/drawing/2014/main" id="{06757BF3-2CF4-4C3B-BEF7-CB63F5DC8233}"/>
+                <a16:creationId xmlns:a16="http://schemas.microsoft.com/office/drawing/2014/main" id="{6603EA76-6705-40FE-B028-707B26202548}"/>
               </a:ext>
             </a:extLst>
           </p:cNvPr>
@@ -8259,7 +8261,7 @@
           <p:cNvPr id="7" name="">
             <a:extLst xmlns:a="http://schemas.openxmlformats.org/drawingml/2006/main">
               <a:ext uri="{FF2B5EF4-FFF2-40B4-BE49-F238E27FC236}">
-                <a16:creationId xmlns:a16="http://schemas.microsoft.com/office/drawing/2014/main" id="{08E647D9-AE93-472A-9F2C-6DB25CE99738}"/>
+                <a16:creationId xmlns:a16="http://schemas.microsoft.com/office/drawing/2014/main" id="{F398F36C-DDE6-453E-BFE7-B533AE9C8669}"/>
               </a:ext>
             </a:extLst>
           </p:cNvPr>
@@ -8350,7 +8352,7 @@
           <p:cNvPr id="8" name="">
             <a:extLst xmlns:a="http://schemas.openxmlformats.org/drawingml/2006/main">
               <a:ext uri="{FF2B5EF4-FFF2-40B4-BE49-F238E27FC236}">
-                <a16:creationId xmlns:a16="http://schemas.microsoft.com/office/drawing/2014/main" id="{12A1935D-0C5A-42FB-A7AE-4237519D6BBF}"/>
+                <a16:creationId xmlns:a16="http://schemas.microsoft.com/office/drawing/2014/main" id="{C505D091-32E8-475D-A13D-3707230D8CBE}"/>
               </a:ext>
             </a:extLst>
           </p:cNvPr>
@@ -8416,7 +8418,7 @@
     </p:spTree>
     <p:extLst>
       <p:ext uri="{BB962C8B-B14F-4D97-AF65-F5344CB8AC3E}">
-        <p14:creationId xmlns:p14="http://schemas.microsoft.com/office/powerpoint/2010/main" val="1956617019"/>
+        <p14:creationId xmlns:p14="http://schemas.microsoft.com/office/powerpoint/2010/main" val="1200055005"/>
       </p:ext>
     </p:extLst>
   </p:cSld>
@@ -8447,7 +8449,7 @@
           <p:cNvPr id="9" name="">
             <a:extLst xmlns:a="http://schemas.openxmlformats.org/drawingml/2006/main">
               <a:ext uri="{FF2B5EF4-FFF2-40B4-BE49-F238E27FC236}">
-                <a16:creationId xmlns:a16="http://schemas.microsoft.com/office/drawing/2014/main" id="{711BF4CC-CF0B-4E26-813B-176C4A3B55D1}"/>
+                <a16:creationId xmlns:a16="http://schemas.microsoft.com/office/drawing/2014/main" id="{BAEB1B38-6389-4048-AE34-E40E11CF03EB}"/>
               </a:ext>
             </a:extLst>
           </p:cNvPr>
@@ -8515,7 +8517,7 @@
           <p:cNvPr id="2" name="">
             <a:extLst xmlns:a="http://schemas.openxmlformats.org/drawingml/2006/main">
               <a:ext uri="{FF2B5EF4-FFF2-40B4-BE49-F238E27FC236}">
-                <a16:creationId xmlns:a16="http://schemas.microsoft.com/office/drawing/2014/main" id="{4CF847C5-64F2-4A65-802A-ABEF06592E64}"/>
+                <a16:creationId xmlns:a16="http://schemas.microsoft.com/office/drawing/2014/main" id="{D2999069-CACA-40A8-B106-02401F731D3C}"/>
               </a:ext>
             </a:extLst>
           </p:cNvPr>
@@ -8583,7 +8585,7 @@
           <p:cNvPr id="3" name="">
             <a:extLst xmlns:a="http://schemas.openxmlformats.org/drawingml/2006/main">
               <a:ext uri="{FF2B5EF4-FFF2-40B4-BE49-F238E27FC236}">
-                <a16:creationId xmlns:a16="http://schemas.microsoft.com/office/drawing/2014/main" id="{7230F6BC-1946-4C89-9902-22BBBD2295E8}"/>
+                <a16:creationId xmlns:a16="http://schemas.microsoft.com/office/drawing/2014/main" id="{3B83E677-3896-4F45-9689-C0C7FA8A1410}"/>
               </a:ext>
             </a:extLst>
           </p:cNvPr>
@@ -8613,7 +8615,7 @@
           <p:cNvPr id="4" name="">
             <a:extLst xmlns:a="http://schemas.openxmlformats.org/drawingml/2006/main">
               <a:ext uri="{FF2B5EF4-FFF2-40B4-BE49-F238E27FC236}">
-                <a16:creationId xmlns:a16="http://schemas.microsoft.com/office/drawing/2014/main" id="{1FFABA28-A92F-4258-B7C1-04E55EBA9CE1}"/>
+                <a16:creationId xmlns:a16="http://schemas.microsoft.com/office/drawing/2014/main" id="{3A64AA94-EA55-4347-9B8C-3F2280ACA040}"/>
               </a:ext>
             </a:extLst>
           </p:cNvPr>
@@ -9088,7 +9090,7 @@
           <p:cNvPr id="5" name="">
             <a:extLst xmlns:a="http://schemas.openxmlformats.org/drawingml/2006/main">
               <a:ext uri="{FF2B5EF4-FFF2-40B4-BE49-F238E27FC236}">
-                <a16:creationId xmlns:a16="http://schemas.microsoft.com/office/drawing/2014/main" id="{FDDFB998-0DCC-4F78-8865-D91C1254D2AA}"/>
+                <a16:creationId xmlns:a16="http://schemas.microsoft.com/office/drawing/2014/main" id="{427FAEB7-32C3-4522-A833-BB4D34A0C412}"/>
               </a:ext>
             </a:extLst>
           </p:cNvPr>
@@ -9156,7 +9158,7 @@
           <p:cNvPr id="6" name="">
             <a:extLst xmlns:a="http://schemas.openxmlformats.org/drawingml/2006/main">
               <a:ext uri="{FF2B5EF4-FFF2-40B4-BE49-F238E27FC236}">
-                <a16:creationId xmlns:a16="http://schemas.microsoft.com/office/drawing/2014/main" id="{0A1075EB-F733-4967-934C-E7333792C071}"/>
+                <a16:creationId xmlns:a16="http://schemas.microsoft.com/office/drawing/2014/main" id="{31A7C380-2DA3-409F-8C49-6C96E19E74D2}"/>
               </a:ext>
             </a:extLst>
           </p:cNvPr>
@@ -9247,7 +9249,7 @@
           <p:cNvPr id="7" name="">
             <a:extLst xmlns:a="http://schemas.openxmlformats.org/drawingml/2006/main">
               <a:ext uri="{FF2B5EF4-FFF2-40B4-BE49-F238E27FC236}">
-                <a16:creationId xmlns:a16="http://schemas.microsoft.com/office/drawing/2014/main" id="{031CEB49-CDDE-4C87-86D3-3C2A50DAB31F}"/>
+                <a16:creationId xmlns:a16="http://schemas.microsoft.com/office/drawing/2014/main" id="{24FF7E85-E7D7-49B6-AEE6-2C84A9C95CAC}"/>
               </a:ext>
             </a:extLst>
           </p:cNvPr>
@@ -9315,7 +9317,7 @@
           <p:cNvPr id="8" name="">
             <a:extLst xmlns:a="http://schemas.openxmlformats.org/drawingml/2006/main">
               <a:ext uri="{FF2B5EF4-FFF2-40B4-BE49-F238E27FC236}">
-                <a16:creationId xmlns:a16="http://schemas.microsoft.com/office/drawing/2014/main" id="{DE4F6074-5DE3-4C53-94EC-E8B2760053D4}"/>
+                <a16:creationId xmlns:a16="http://schemas.microsoft.com/office/drawing/2014/main" id="{B865B177-3951-40E2-8D3F-2C41E7439CCA}"/>
               </a:ext>
             </a:extLst>
           </p:cNvPr>
@@ -9381,7 +9383,7 @@
     </p:spTree>
     <p:extLst>
       <p:ext uri="{BB962C8B-B14F-4D97-AF65-F5344CB8AC3E}">
-        <p14:creationId xmlns:p14="http://schemas.microsoft.com/office/powerpoint/2010/main" val="1394972497"/>
+        <p14:creationId xmlns:p14="http://schemas.microsoft.com/office/powerpoint/2010/main" val="1486326177"/>
       </p:ext>
     </p:extLst>
   </p:cSld>
@@ -9412,7 +9414,7 @@
           <p:cNvPr id="14" name="">
             <a:extLst xmlns:a="http://schemas.openxmlformats.org/drawingml/2006/main">
               <a:ext uri="{FF2B5EF4-FFF2-40B4-BE49-F238E27FC236}">
-                <a16:creationId xmlns:a16="http://schemas.microsoft.com/office/drawing/2014/main" id="{CB3A91DA-0604-4225-A1CF-14CF8920221D}"/>
+                <a16:creationId xmlns:a16="http://schemas.microsoft.com/office/drawing/2014/main" id="{57813E2D-AF00-4869-AC36-E8F3E7D3227B}"/>
               </a:ext>
             </a:extLst>
           </p:cNvPr>
@@ -9480,7 +9482,7 @@
           <p:cNvPr id="2" name="">
             <a:extLst xmlns:a="http://schemas.openxmlformats.org/drawingml/2006/main">
               <a:ext uri="{FF2B5EF4-FFF2-40B4-BE49-F238E27FC236}">
-                <a16:creationId xmlns:a16="http://schemas.microsoft.com/office/drawing/2014/main" id="{E34EA78E-AB37-45FA-B4D2-FE598F3F6D1A}"/>
+                <a16:creationId xmlns:a16="http://schemas.microsoft.com/office/drawing/2014/main" id="{61585534-6110-4AE4-9820-FE88FDB04D11}"/>
               </a:ext>
             </a:extLst>
           </p:cNvPr>
@@ -9548,7 +9550,7 @@
           <p:cNvPr id="3" name="">
             <a:extLst xmlns:a="http://schemas.openxmlformats.org/drawingml/2006/main">
               <a:ext uri="{FF2B5EF4-FFF2-40B4-BE49-F238E27FC236}">
-                <a16:creationId xmlns:a16="http://schemas.microsoft.com/office/drawing/2014/main" id="{E15EE8FE-006E-42B4-AC83-278F2CBFF9AB}"/>
+                <a16:creationId xmlns:a16="http://schemas.microsoft.com/office/drawing/2014/main" id="{7E9743AD-F545-49C4-AA9B-527C209370F2}"/>
               </a:ext>
             </a:extLst>
           </p:cNvPr>
@@ -9578,7 +9580,7 @@
           <p:cNvPr id="4" name="">
             <a:extLst xmlns:a="http://schemas.openxmlformats.org/drawingml/2006/main">
               <a:ext uri="{FF2B5EF4-FFF2-40B4-BE49-F238E27FC236}">
-                <a16:creationId xmlns:a16="http://schemas.microsoft.com/office/drawing/2014/main" id="{EACDBDC1-3608-4E49-9CE7-5A2E9620FCB5}"/>
+                <a16:creationId xmlns:a16="http://schemas.microsoft.com/office/drawing/2014/main" id="{29710064-FE40-4792-9654-3B7AC3D059E0}"/>
               </a:ext>
             </a:extLst>
           </p:cNvPr>
@@ -9646,7 +9648,7 @@
           <p:cNvPr id="5" name="">
             <a:extLst xmlns:a="http://schemas.openxmlformats.org/drawingml/2006/main">
               <a:ext uri="{FF2B5EF4-FFF2-40B4-BE49-F238E27FC236}">
-                <a16:creationId xmlns:a16="http://schemas.microsoft.com/office/drawing/2014/main" id="{78B5F9DA-FEC7-4282-B8CB-AC275BF222D7}"/>
+                <a16:creationId xmlns:a16="http://schemas.microsoft.com/office/drawing/2014/main" id="{40B4402B-242F-4C54-9D16-0E9B7A154FE0}"/>
               </a:ext>
             </a:extLst>
           </p:cNvPr>
@@ -9829,7 +9831,7 @@
           <p:cNvPr id="6" name="">
             <a:extLst xmlns:a="http://schemas.openxmlformats.org/drawingml/2006/main">
               <a:ext uri="{FF2B5EF4-FFF2-40B4-BE49-F238E27FC236}">
-                <a16:creationId xmlns:a16="http://schemas.microsoft.com/office/drawing/2014/main" id="{0A4826D9-4E9A-4804-BE21-667028A5761E}"/>
+                <a16:creationId xmlns:a16="http://schemas.microsoft.com/office/drawing/2014/main" id="{E7625243-9A88-427F-AF7C-81C97136A0EF}"/>
               </a:ext>
             </a:extLst>
           </p:cNvPr>
@@ -9897,7 +9899,7 @@
           <p:cNvPr id="7" name="">
             <a:extLst xmlns:a="http://schemas.openxmlformats.org/drawingml/2006/main">
               <a:ext uri="{FF2B5EF4-FFF2-40B4-BE49-F238E27FC236}">
-                <a16:creationId xmlns:a16="http://schemas.microsoft.com/office/drawing/2014/main" id="{48D31D96-3811-4AE2-BA79-AC75D8D3C8B5}"/>
+                <a16:creationId xmlns:a16="http://schemas.microsoft.com/office/drawing/2014/main" id="{347921C3-9314-46B4-8707-4576F11B6B80}"/>
               </a:ext>
             </a:extLst>
           </p:cNvPr>
@@ -10034,7 +10036,7 @@
           <p:cNvPr id="8" name="">
             <a:extLst xmlns:a="http://schemas.openxmlformats.org/drawingml/2006/main">
               <a:ext uri="{FF2B5EF4-FFF2-40B4-BE49-F238E27FC236}">
-                <a16:creationId xmlns:a16="http://schemas.microsoft.com/office/drawing/2014/main" id="{A4930BF9-4A4F-415F-A4BC-68D42B89312F}"/>
+                <a16:creationId xmlns:a16="http://schemas.microsoft.com/office/drawing/2014/main" id="{1E1A295C-61B7-4129-842F-80CE5BF4F71D}"/>
               </a:ext>
             </a:extLst>
           </p:cNvPr>
@@ -10102,7 +10104,7 @@
           <p:cNvPr id="9" name="">
             <a:extLst xmlns:a="http://schemas.openxmlformats.org/drawingml/2006/main">
               <a:ext uri="{FF2B5EF4-FFF2-40B4-BE49-F238E27FC236}">
-                <a16:creationId xmlns:a16="http://schemas.microsoft.com/office/drawing/2014/main" id="{401DBC04-5057-418E-995E-1B0DCF647FB5}"/>
+                <a16:creationId xmlns:a16="http://schemas.microsoft.com/office/drawing/2014/main" id="{D3E06D9B-927E-4C68-8124-04D2D387634B}"/>
               </a:ext>
             </a:extLst>
           </p:cNvPr>
@@ -10226,7 +10228,7 @@
           <p:cNvPr id="10" name="">
             <a:extLst xmlns:a="http://schemas.openxmlformats.org/drawingml/2006/main">
               <a:ext uri="{FF2B5EF4-FFF2-40B4-BE49-F238E27FC236}">
-                <a16:creationId xmlns:a16="http://schemas.microsoft.com/office/drawing/2014/main" id="{4AF329EC-C5E0-4970-87CD-A7B1B948EEE6}"/>
+                <a16:creationId xmlns:a16="http://schemas.microsoft.com/office/drawing/2014/main" id="{0F1363CC-300B-4911-95D0-D2C5055E9E21}"/>
               </a:ext>
             </a:extLst>
           </p:cNvPr>
@@ -10294,7 +10296,7 @@
           <p:cNvPr id="11" name="">
             <a:extLst xmlns:a="http://schemas.openxmlformats.org/drawingml/2006/main">
               <a:ext uri="{FF2B5EF4-FFF2-40B4-BE49-F238E27FC236}">
-                <a16:creationId xmlns:a16="http://schemas.microsoft.com/office/drawing/2014/main" id="{1765C509-E6FB-4333-94BF-780FBC40CDD4}"/>
+                <a16:creationId xmlns:a16="http://schemas.microsoft.com/office/drawing/2014/main" id="{DE8E2208-738F-4F04-86CB-0513AEC7BDAF}"/>
               </a:ext>
             </a:extLst>
           </p:cNvPr>
@@ -10362,7 +10364,7 @@
           <p:cNvPr id="12" name="">
             <a:extLst xmlns:a="http://schemas.openxmlformats.org/drawingml/2006/main">
               <a:ext uri="{FF2B5EF4-FFF2-40B4-BE49-F238E27FC236}">
-                <a16:creationId xmlns:a16="http://schemas.microsoft.com/office/drawing/2014/main" id="{A1F16ABF-8A03-4D89-AE67-1E01C8488689}"/>
+                <a16:creationId xmlns:a16="http://schemas.microsoft.com/office/drawing/2014/main" id="{33C0A3F3-265B-41C2-9F54-482C68A8B0DB}"/>
               </a:ext>
             </a:extLst>
           </p:cNvPr>
@@ -10430,7 +10432,7 @@
           <p:cNvPr id="13" name="">
             <a:extLst xmlns:a="http://schemas.openxmlformats.org/drawingml/2006/main">
               <a:ext uri="{FF2B5EF4-FFF2-40B4-BE49-F238E27FC236}">
-                <a16:creationId xmlns:a16="http://schemas.microsoft.com/office/drawing/2014/main" id="{C23763DC-E6F0-4933-8B40-3C8C3C38369E}"/>
+                <a16:creationId xmlns:a16="http://schemas.microsoft.com/office/drawing/2014/main" id="{3AAB4A32-33BE-4999-8ED9-7C82C86742D4}"/>
               </a:ext>
             </a:extLst>
           </p:cNvPr>
@@ -10496,7 +10498,7 @@
     </p:spTree>
     <p:extLst>
       <p:ext uri="{BB962C8B-B14F-4D97-AF65-F5344CB8AC3E}">
-        <p14:creationId xmlns:p14="http://schemas.microsoft.com/office/powerpoint/2010/main" val="1558517750"/>
+        <p14:creationId xmlns:p14="http://schemas.microsoft.com/office/powerpoint/2010/main" val="2053065417"/>
       </p:ext>
     </p:extLst>
   </p:cSld>
@@ -10527,7 +10529,7 @@
           <p:cNvPr id="9" name="">
             <a:extLst xmlns:a="http://schemas.openxmlformats.org/drawingml/2006/main">
               <a:ext uri="{FF2B5EF4-FFF2-40B4-BE49-F238E27FC236}">
-                <a16:creationId xmlns:a16="http://schemas.microsoft.com/office/drawing/2014/main" id="{4D32A50E-BF79-497D-9164-868997F2EBEF}"/>
+                <a16:creationId xmlns:a16="http://schemas.microsoft.com/office/drawing/2014/main" id="{BA804B60-4400-4409-BDC2-FE48ECFF02E7}"/>
               </a:ext>
             </a:extLst>
           </p:cNvPr>
@@ -10595,7 +10597,7 @@
           <p:cNvPr id="2" name="">
             <a:extLst xmlns:a="http://schemas.openxmlformats.org/drawingml/2006/main">
               <a:ext uri="{FF2B5EF4-FFF2-40B4-BE49-F238E27FC236}">
-                <a16:creationId xmlns:a16="http://schemas.microsoft.com/office/drawing/2014/main" id="{7F6AE9A3-6FD1-4362-AA77-398D3874A391}"/>
+                <a16:creationId xmlns:a16="http://schemas.microsoft.com/office/drawing/2014/main" id="{C9F2332A-5FD1-467E-BCF0-CC2AFE5D53BB}"/>
               </a:ext>
             </a:extLst>
           </p:cNvPr>
@@ -10663,7 +10665,7 @@
           <p:cNvPr id="3" name="">
             <a:extLst xmlns:a="http://schemas.openxmlformats.org/drawingml/2006/main">
               <a:ext uri="{FF2B5EF4-FFF2-40B4-BE49-F238E27FC236}">
-                <a16:creationId xmlns:a16="http://schemas.microsoft.com/office/drawing/2014/main" id="{406FAC52-574A-4396-90BF-54609032CC0A}"/>
+                <a16:creationId xmlns:a16="http://schemas.microsoft.com/office/drawing/2014/main" id="{D332ECFF-14EA-47BC-81A0-D2962923670B}"/>
               </a:ext>
             </a:extLst>
           </p:cNvPr>
@@ -10693,7 +10695,7 @@
           <p:cNvPr id="4" name="">
             <a:extLst xmlns:a="http://schemas.openxmlformats.org/drawingml/2006/main">
               <a:ext uri="{FF2B5EF4-FFF2-40B4-BE49-F238E27FC236}">
-                <a16:creationId xmlns:a16="http://schemas.microsoft.com/office/drawing/2014/main" id="{985A5E86-B669-4D65-95CB-4DA4952D77DD}"/>
+                <a16:creationId xmlns:a16="http://schemas.microsoft.com/office/drawing/2014/main" id="{B13AA29C-83BE-4F10-A187-B25310FD7C6D}"/>
               </a:ext>
             </a:extLst>
           </p:cNvPr>
@@ -10761,7 +10763,7 @@
           <p:cNvPr id="5" name="">
             <a:extLst xmlns:a="http://schemas.openxmlformats.org/drawingml/2006/main">
               <a:ext uri="{FF2B5EF4-FFF2-40B4-BE49-F238E27FC236}">
-                <a16:creationId xmlns:a16="http://schemas.microsoft.com/office/drawing/2014/main" id="{6AEE4BD9-57C2-40E8-8C73-018FD6C0662A}"/>
+                <a16:creationId xmlns:a16="http://schemas.microsoft.com/office/drawing/2014/main" id="{148BD1CE-B37C-4CE3-9352-E0A60D76779A}"/>
               </a:ext>
             </a:extLst>
           </p:cNvPr>
@@ -10829,7 +10831,7 @@
           <p:cNvPr id="6" name="">
             <a:extLst xmlns:a="http://schemas.openxmlformats.org/drawingml/2006/main">
               <a:ext uri="{FF2B5EF4-FFF2-40B4-BE49-F238E27FC236}">
-                <a16:creationId xmlns:a16="http://schemas.microsoft.com/office/drawing/2014/main" id="{F4D3DEB9-B40D-4E25-8DF2-54768D93A049}"/>
+                <a16:creationId xmlns:a16="http://schemas.microsoft.com/office/drawing/2014/main" id="{638B49EB-C9DF-4740-9570-2C01B324CC42}"/>
               </a:ext>
             </a:extLst>
           </p:cNvPr>
@@ -10897,7 +10899,7 @@
           <p:cNvPr id="7" name="">
             <a:extLst xmlns:a="http://schemas.openxmlformats.org/drawingml/2006/main">
               <a:ext uri="{FF2B5EF4-FFF2-40B4-BE49-F238E27FC236}">
-                <a16:creationId xmlns:a16="http://schemas.microsoft.com/office/drawing/2014/main" id="{D8E8FFBB-634D-4A33-98A7-F5DBCFFD3012}"/>
+                <a16:creationId xmlns:a16="http://schemas.microsoft.com/office/drawing/2014/main" id="{2D87E067-E332-4AB8-9FAF-C77B81A330C6}"/>
               </a:ext>
             </a:extLst>
           </p:cNvPr>
@@ -10965,7 +10967,7 @@
           <p:cNvPr id="8" name="">
             <a:extLst xmlns:a="http://schemas.openxmlformats.org/drawingml/2006/main">
               <a:ext uri="{FF2B5EF4-FFF2-40B4-BE49-F238E27FC236}">
-                <a16:creationId xmlns:a16="http://schemas.microsoft.com/office/drawing/2014/main" id="{6E3B6142-2D66-42F8-847C-E743DB4ABDF8}"/>
+                <a16:creationId xmlns:a16="http://schemas.microsoft.com/office/drawing/2014/main" id="{3053A745-DAD9-495C-A40F-41F949451C19}"/>
               </a:ext>
             </a:extLst>
           </p:cNvPr>
@@ -11031,7 +11033,7 @@
     </p:spTree>
     <p:extLst>
       <p:ext uri="{BB962C8B-B14F-4D97-AF65-F5344CB8AC3E}">
-        <p14:creationId xmlns:p14="http://schemas.microsoft.com/office/powerpoint/2010/main" val="61427265"/>
+        <p14:creationId xmlns:p14="http://schemas.microsoft.com/office/powerpoint/2010/main" val="778074131"/>
       </p:ext>
     </p:extLst>
   </p:cSld>
@@ -11062,7 +11064,7 @@
           <p:cNvPr id="20" name="">
             <a:extLst xmlns:a="http://schemas.openxmlformats.org/drawingml/2006/main">
               <a:ext uri="{FF2B5EF4-FFF2-40B4-BE49-F238E27FC236}">
-                <a16:creationId xmlns:a16="http://schemas.microsoft.com/office/drawing/2014/main" id="{89E8452B-A217-4558-B92E-212716D78D4E}"/>
+                <a16:creationId xmlns:a16="http://schemas.microsoft.com/office/drawing/2014/main" id="{27633638-0810-4F9E-83A8-FE2EF94A992B}"/>
               </a:ext>
             </a:extLst>
           </p:cNvPr>
@@ -11130,7 +11132,7 @@
           <p:cNvPr id="2" name="">
             <a:extLst xmlns:a="http://schemas.openxmlformats.org/drawingml/2006/main">
               <a:ext uri="{FF2B5EF4-FFF2-40B4-BE49-F238E27FC236}">
-                <a16:creationId xmlns:a16="http://schemas.microsoft.com/office/drawing/2014/main" id="{AC1FE39C-466E-4C29-A931-82F5E0BB492B}"/>
+                <a16:creationId xmlns:a16="http://schemas.microsoft.com/office/drawing/2014/main" id="{12238F1C-C4FB-4348-9FA2-6A6088A3AF7A}"/>
               </a:ext>
             </a:extLst>
           </p:cNvPr>
@@ -11198,7 +11200,7 @@
           <p:cNvPr id="3" name="">
             <a:extLst xmlns:a="http://schemas.openxmlformats.org/drawingml/2006/main">
               <a:ext uri="{FF2B5EF4-FFF2-40B4-BE49-F238E27FC236}">
-                <a16:creationId xmlns:a16="http://schemas.microsoft.com/office/drawing/2014/main" id="{5E5E42BE-7F53-46B2-B46D-788F84A64E56}"/>
+                <a16:creationId xmlns:a16="http://schemas.microsoft.com/office/drawing/2014/main" id="{BB0A62D3-4C4F-4C53-B772-B1782B5DB591}"/>
               </a:ext>
             </a:extLst>
           </p:cNvPr>
@@ -11228,7 +11230,7 @@
           <p:cNvPr id="4" name="">
             <a:extLst xmlns:a="http://schemas.openxmlformats.org/drawingml/2006/main">
               <a:ext uri="{FF2B5EF4-FFF2-40B4-BE49-F238E27FC236}">
-                <a16:creationId xmlns:a16="http://schemas.microsoft.com/office/drawing/2014/main" id="{DF302636-B7FA-4F07-B69B-B4AA5C91937C}"/>
+                <a16:creationId xmlns:a16="http://schemas.microsoft.com/office/drawing/2014/main" id="{AF4F999D-9802-4DCE-B887-1489F7D2E21F}"/>
               </a:ext>
             </a:extLst>
           </p:cNvPr>
@@ -11262,7 +11264,7 @@
           <p:cNvPr id="5" name="">
             <a:extLst xmlns:a="http://schemas.openxmlformats.org/drawingml/2006/main">
               <a:ext uri="{FF2B5EF4-FFF2-40B4-BE49-F238E27FC236}">
-                <a16:creationId xmlns:a16="http://schemas.microsoft.com/office/drawing/2014/main" id="{ABF300C2-B719-4F69-B81F-992BBA515096}"/>
+                <a16:creationId xmlns:a16="http://schemas.microsoft.com/office/drawing/2014/main" id="{7283569A-2915-4464-84BB-C66FB197C1C7}"/>
               </a:ext>
             </a:extLst>
           </p:cNvPr>
@@ -11330,7 +11332,7 @@
           <p:cNvPr id="6" name="">
             <a:extLst xmlns:a="http://schemas.openxmlformats.org/drawingml/2006/main">
               <a:ext uri="{FF2B5EF4-FFF2-40B4-BE49-F238E27FC236}">
-                <a16:creationId xmlns:a16="http://schemas.microsoft.com/office/drawing/2014/main" id="{62ECB2DF-8398-4782-A14C-5493F880B7CC}"/>
+                <a16:creationId xmlns:a16="http://schemas.microsoft.com/office/drawing/2014/main" id="{E57E8250-6FB2-4DF5-BA88-E2C588B341E4}"/>
               </a:ext>
             </a:extLst>
           </p:cNvPr>
@@ -11398,7 +11400,7 @@
           <p:cNvPr id="7" name="">
             <a:extLst xmlns:a="http://schemas.openxmlformats.org/drawingml/2006/main">
               <a:ext uri="{FF2B5EF4-FFF2-40B4-BE49-F238E27FC236}">
-                <a16:creationId xmlns:a16="http://schemas.microsoft.com/office/drawing/2014/main" id="{53CDC1E3-8497-49F1-BB78-3EFF355FA1E6}"/>
+                <a16:creationId xmlns:a16="http://schemas.microsoft.com/office/drawing/2014/main" id="{DCC21C80-1B4E-4427-B771-141FCA996532}"/>
               </a:ext>
             </a:extLst>
           </p:cNvPr>
@@ -11432,7 +11434,7 @@
           <p:cNvPr id="8" name="">
             <a:extLst xmlns:a="http://schemas.openxmlformats.org/drawingml/2006/main">
               <a:ext uri="{FF2B5EF4-FFF2-40B4-BE49-F238E27FC236}">
-                <a16:creationId xmlns:a16="http://schemas.microsoft.com/office/drawing/2014/main" id="{4DDEEB28-0A2A-4C31-8C30-BDA5624F3C88}"/>
+                <a16:creationId xmlns:a16="http://schemas.microsoft.com/office/drawing/2014/main" id="{99AB4730-AAC4-4863-B453-CABDF3CBE23C}"/>
               </a:ext>
             </a:extLst>
           </p:cNvPr>
@@ -11500,7 +11502,7 @@
           <p:cNvPr id="9" name="">
             <a:extLst xmlns:a="http://schemas.openxmlformats.org/drawingml/2006/main">
               <a:ext uri="{FF2B5EF4-FFF2-40B4-BE49-F238E27FC236}">
-                <a16:creationId xmlns:a16="http://schemas.microsoft.com/office/drawing/2014/main" id="{B9C9A74F-AB0A-47F2-B97B-7EC38E680A3A}"/>
+                <a16:creationId xmlns:a16="http://schemas.microsoft.com/office/drawing/2014/main" id="{509534DA-619A-4962-AA60-626C47F768C1}"/>
               </a:ext>
             </a:extLst>
           </p:cNvPr>
@@ -11568,7 +11570,7 @@
           <p:cNvPr id="10" name="">
             <a:extLst xmlns:a="http://schemas.openxmlformats.org/drawingml/2006/main">
               <a:ext uri="{FF2B5EF4-FFF2-40B4-BE49-F238E27FC236}">
-                <a16:creationId xmlns:a16="http://schemas.microsoft.com/office/drawing/2014/main" id="{426E5FEC-2A10-49A4-9470-A7CEF75513DC}"/>
+                <a16:creationId xmlns:a16="http://schemas.microsoft.com/office/drawing/2014/main" id="{07778CCF-7F8B-4B0E-9D61-386E5FD9C57C}"/>
               </a:ext>
             </a:extLst>
           </p:cNvPr>
@@ -11602,7 +11604,7 @@
           <p:cNvPr id="11" name="">
             <a:extLst xmlns:a="http://schemas.openxmlformats.org/drawingml/2006/main">
               <a:ext uri="{FF2B5EF4-FFF2-40B4-BE49-F238E27FC236}">
-                <a16:creationId xmlns:a16="http://schemas.microsoft.com/office/drawing/2014/main" id="{9331C280-6434-45C6-8C8E-C3F3271A27E3}"/>
+                <a16:creationId xmlns:a16="http://schemas.microsoft.com/office/drawing/2014/main" id="{5902029E-E9F6-44C4-AF56-057065496333}"/>
               </a:ext>
             </a:extLst>
           </p:cNvPr>
@@ -11670,7 +11672,7 @@
           <p:cNvPr id="12" name="">
             <a:extLst xmlns:a="http://schemas.openxmlformats.org/drawingml/2006/main">
               <a:ext uri="{FF2B5EF4-FFF2-40B4-BE49-F238E27FC236}">
-                <a16:creationId xmlns:a16="http://schemas.microsoft.com/office/drawing/2014/main" id="{C9C1409A-A127-4F36-9451-D25BBF2DEB20}"/>
+                <a16:creationId xmlns:a16="http://schemas.microsoft.com/office/drawing/2014/main" id="{26359E42-CB42-4AB1-8621-4909BB9A5FFD}"/>
               </a:ext>
             </a:extLst>
           </p:cNvPr>
@@ -11738,7 +11740,7 @@
           <p:cNvPr id="13" name="">
             <a:extLst xmlns:a="http://schemas.openxmlformats.org/drawingml/2006/main">
               <a:ext uri="{FF2B5EF4-FFF2-40B4-BE49-F238E27FC236}">
-                <a16:creationId xmlns:a16="http://schemas.microsoft.com/office/drawing/2014/main" id="{94583400-8E05-4AB4-A4A3-D935FB721DCA}"/>
+                <a16:creationId xmlns:a16="http://schemas.microsoft.com/office/drawing/2014/main" id="{53D702BC-3EDD-4EEB-A910-578DDF17D15B}"/>
               </a:ext>
             </a:extLst>
           </p:cNvPr>
@@ -11772,7 +11774,7 @@
           <p:cNvPr id="14" name="">
             <a:extLst xmlns:a="http://schemas.openxmlformats.org/drawingml/2006/main">
               <a:ext uri="{FF2B5EF4-FFF2-40B4-BE49-F238E27FC236}">
-                <a16:creationId xmlns:a16="http://schemas.microsoft.com/office/drawing/2014/main" id="{DE78F731-988D-457E-905C-E37521932BCF}"/>
+                <a16:creationId xmlns:a16="http://schemas.microsoft.com/office/drawing/2014/main" id="{D5E9DC5C-3365-47B4-A757-A829AD5249B9}"/>
               </a:ext>
             </a:extLst>
           </p:cNvPr>
@@ -11840,7 +11842,7 @@
           <p:cNvPr id="15" name="">
             <a:extLst xmlns:a="http://schemas.openxmlformats.org/drawingml/2006/main">
               <a:ext uri="{FF2B5EF4-FFF2-40B4-BE49-F238E27FC236}">
-                <a16:creationId xmlns:a16="http://schemas.microsoft.com/office/drawing/2014/main" id="{31788F54-1D70-4BFE-B58C-1D2148B00175}"/>
+                <a16:creationId xmlns:a16="http://schemas.microsoft.com/office/drawing/2014/main" id="{59410619-9E14-4225-8D17-256C3BBD9926}"/>
               </a:ext>
             </a:extLst>
           </p:cNvPr>
@@ -11908,7 +11910,7 @@
           <p:cNvPr id="16" name="">
             <a:extLst xmlns:a="http://schemas.openxmlformats.org/drawingml/2006/main">
               <a:ext uri="{FF2B5EF4-FFF2-40B4-BE49-F238E27FC236}">
-                <a16:creationId xmlns:a16="http://schemas.microsoft.com/office/drawing/2014/main" id="{A5DC2774-A595-46ED-AFD4-48902A1DBE29}"/>
+                <a16:creationId xmlns:a16="http://schemas.microsoft.com/office/drawing/2014/main" id="{4EC3D1C1-EBE7-466E-B831-CF089379854E}"/>
               </a:ext>
             </a:extLst>
           </p:cNvPr>
@@ -11918,7 +11920,7 @@
           <p:nvPr/>
         </p:nvPicPr>
         <p:blipFill>
-          <a:blip xmlns:r="http://schemas.openxmlformats.org/officeDocument/2006/relationships" xmlns:a="http://schemas.openxmlformats.org/drawingml/2006/main" r:embed="Rf65171d4b5894af1"/>
+          <a:blip xmlns:r="http://schemas.openxmlformats.org/officeDocument/2006/relationships" xmlns:a="http://schemas.openxmlformats.org/drawingml/2006/main" r:embed="R1e5826cf8a8b4490"/>
           <a:stretch xmlns:a="http://schemas.openxmlformats.org/drawingml/2006/main"/>
         </p:blipFill>
         <p:spPr>
@@ -11936,7 +11938,7 @@
           <p:cNvPr id="17" name="">
             <a:extLst xmlns:a="http://schemas.openxmlformats.org/drawingml/2006/main">
               <a:ext uri="{FF2B5EF4-FFF2-40B4-BE49-F238E27FC236}">
-                <a16:creationId xmlns:a16="http://schemas.microsoft.com/office/drawing/2014/main" id="{728D5002-7087-47C7-94AA-E71E3ED28209}"/>
+                <a16:creationId xmlns:a16="http://schemas.microsoft.com/office/drawing/2014/main" id="{3068413A-C83B-4C23-8A96-58618FFDC514}"/>
               </a:ext>
             </a:extLst>
           </p:cNvPr>
@@ -12004,7 +12006,7 @@
           <p:cNvPr id="18" name="">
             <a:extLst xmlns:a="http://schemas.openxmlformats.org/drawingml/2006/main">
               <a:ext uri="{FF2B5EF4-FFF2-40B4-BE49-F238E27FC236}">
-                <a16:creationId xmlns:a16="http://schemas.microsoft.com/office/drawing/2014/main" id="{6B92EE11-2B2F-4922-BC5E-5CD50E32B391}"/>
+                <a16:creationId xmlns:a16="http://schemas.microsoft.com/office/drawing/2014/main" id="{0C7E402B-C3DF-44F0-96FC-54F00F2513E5}"/>
               </a:ext>
             </a:extLst>
           </p:cNvPr>
@@ -12164,7 +12166,7 @@
           <p:cNvPr id="19" name="">
             <a:extLst xmlns:a="http://schemas.openxmlformats.org/drawingml/2006/main">
               <a:ext uri="{FF2B5EF4-FFF2-40B4-BE49-F238E27FC236}">
-                <a16:creationId xmlns:a16="http://schemas.microsoft.com/office/drawing/2014/main" id="{DFBE98CA-84D0-4DDF-A769-0A7E9A44398B}"/>
+                <a16:creationId xmlns:a16="http://schemas.microsoft.com/office/drawing/2014/main" id="{A2C700ED-232C-4000-B415-6C1C075C35A4}"/>
               </a:ext>
             </a:extLst>
           </p:cNvPr>
@@ -12230,7 +12232,7 @@
     </p:spTree>
     <p:extLst>
       <p:ext uri="{BB962C8B-B14F-4D97-AF65-F5344CB8AC3E}">
-        <p14:creationId xmlns:p14="http://schemas.microsoft.com/office/powerpoint/2010/main" val="1203503392"/>
+        <p14:creationId xmlns:p14="http://schemas.microsoft.com/office/powerpoint/2010/main" val="1626051725"/>
       </p:ext>
     </p:extLst>
   </p:cSld>
@@ -12261,7 +12263,7 @@
           <p:cNvPr id="21" name="">
             <a:extLst xmlns:a="http://schemas.openxmlformats.org/drawingml/2006/main">
               <a:ext uri="{FF2B5EF4-FFF2-40B4-BE49-F238E27FC236}">
-                <a16:creationId xmlns:a16="http://schemas.microsoft.com/office/drawing/2014/main" id="{3AD56885-19C9-42D2-B4E9-17F58FC13A37}"/>
+                <a16:creationId xmlns:a16="http://schemas.microsoft.com/office/drawing/2014/main" id="{BF2FCE13-5FD8-4863-8164-AE7CD6C5D373}"/>
               </a:ext>
             </a:extLst>
           </p:cNvPr>
@@ -12329,7 +12331,7 @@
           <p:cNvPr id="2" name="">
             <a:extLst xmlns:a="http://schemas.openxmlformats.org/drawingml/2006/main">
               <a:ext uri="{FF2B5EF4-FFF2-40B4-BE49-F238E27FC236}">
-                <a16:creationId xmlns:a16="http://schemas.microsoft.com/office/drawing/2014/main" id="{8A606F3D-134A-4101-8BBD-D058F75644A1}"/>
+                <a16:creationId xmlns:a16="http://schemas.microsoft.com/office/drawing/2014/main" id="{3E5331F8-5094-436F-B42A-29D89EE369A5}"/>
               </a:ext>
             </a:extLst>
           </p:cNvPr>
@@ -12397,7 +12399,7 @@
           <p:cNvPr id="3" name="">
             <a:extLst xmlns:a="http://schemas.openxmlformats.org/drawingml/2006/main">
               <a:ext uri="{FF2B5EF4-FFF2-40B4-BE49-F238E27FC236}">
-                <a16:creationId xmlns:a16="http://schemas.microsoft.com/office/drawing/2014/main" id="{E57884D3-716E-4A47-A560-E16F1D3E5E87}"/>
+                <a16:creationId xmlns:a16="http://schemas.microsoft.com/office/drawing/2014/main" id="{BD823E41-9367-4B8F-9E85-601B02145730}"/>
               </a:ext>
             </a:extLst>
           </p:cNvPr>
@@ -12427,7 +12429,7 @@
           <p:cNvPr id="4" name="">
             <a:extLst xmlns:a="http://schemas.openxmlformats.org/drawingml/2006/main">
               <a:ext uri="{FF2B5EF4-FFF2-40B4-BE49-F238E27FC236}">
-                <a16:creationId xmlns:a16="http://schemas.microsoft.com/office/drawing/2014/main" id="{DAC22A19-85F0-4E5F-917A-C6594129FD96}"/>
+                <a16:creationId xmlns:a16="http://schemas.microsoft.com/office/drawing/2014/main" id="{E13A0CE1-BEB8-4B13-8B5C-0892ABDAEB04}"/>
               </a:ext>
             </a:extLst>
           </p:cNvPr>
@@ -12461,7 +12463,7 @@
           <p:cNvPr id="5" name="">
             <a:extLst xmlns:a="http://schemas.openxmlformats.org/drawingml/2006/main">
               <a:ext uri="{FF2B5EF4-FFF2-40B4-BE49-F238E27FC236}">
-                <a16:creationId xmlns:a16="http://schemas.microsoft.com/office/drawing/2014/main" id="{D92C7B36-F9DF-4CE6-8D3E-F08B642E87F8}"/>
+                <a16:creationId xmlns:a16="http://schemas.microsoft.com/office/drawing/2014/main" id="{DF22114C-0B62-4E7F-BD0C-E5822CDF12EA}"/>
               </a:ext>
             </a:extLst>
           </p:cNvPr>
@@ -12529,7 +12531,7 @@
           <p:cNvPr id="6" name="">
             <a:extLst xmlns:a="http://schemas.openxmlformats.org/drawingml/2006/main">
               <a:ext uri="{FF2B5EF4-FFF2-40B4-BE49-F238E27FC236}">
-                <a16:creationId xmlns:a16="http://schemas.microsoft.com/office/drawing/2014/main" id="{54B2AB3F-2465-4314-B976-F99677BAB953}"/>
+                <a16:creationId xmlns:a16="http://schemas.microsoft.com/office/drawing/2014/main" id="{BBD84893-F355-43DB-B113-BC68444744DD}"/>
               </a:ext>
             </a:extLst>
           </p:cNvPr>
@@ -12597,7 +12599,7 @@
           <p:cNvPr id="7" name="">
             <a:extLst xmlns:a="http://schemas.openxmlformats.org/drawingml/2006/main">
               <a:ext uri="{FF2B5EF4-FFF2-40B4-BE49-F238E27FC236}">
-                <a16:creationId xmlns:a16="http://schemas.microsoft.com/office/drawing/2014/main" id="{5F14A59B-B9B3-4EA5-9DDD-CF630E80F91F}"/>
+                <a16:creationId xmlns:a16="http://schemas.microsoft.com/office/drawing/2014/main" id="{28677B9D-7625-4AFF-A29D-50B707A1F0C6}"/>
               </a:ext>
             </a:extLst>
           </p:cNvPr>
@@ -12665,7 +12667,7 @@
           <p:cNvPr id="8" name="">
             <a:extLst xmlns:a="http://schemas.openxmlformats.org/drawingml/2006/main">
               <a:ext uri="{FF2B5EF4-FFF2-40B4-BE49-F238E27FC236}">
-                <a16:creationId xmlns:a16="http://schemas.microsoft.com/office/drawing/2014/main" id="{F591104E-2F49-4CF1-B7A5-FD8ECEE7BA56}"/>
+                <a16:creationId xmlns:a16="http://schemas.microsoft.com/office/drawing/2014/main" id="{D7978AC1-1381-4B59-B286-4D44351098DF}"/>
               </a:ext>
             </a:extLst>
           </p:cNvPr>
@@ -12699,7 +12701,7 @@
           <p:cNvPr id="9" name="">
             <a:extLst xmlns:a="http://schemas.openxmlformats.org/drawingml/2006/main">
               <a:ext uri="{FF2B5EF4-FFF2-40B4-BE49-F238E27FC236}">
-                <a16:creationId xmlns:a16="http://schemas.microsoft.com/office/drawing/2014/main" id="{1E26796B-A9D9-4704-B089-61479B2ECE3A}"/>
+                <a16:creationId xmlns:a16="http://schemas.microsoft.com/office/drawing/2014/main" id="{581ACCB1-9E88-434D-A108-3E3EA9EB0F21}"/>
               </a:ext>
             </a:extLst>
           </p:cNvPr>
@@ -12767,7 +12769,7 @@
           <p:cNvPr id="10" name="">
             <a:extLst xmlns:a="http://schemas.openxmlformats.org/drawingml/2006/main">
               <a:ext uri="{FF2B5EF4-FFF2-40B4-BE49-F238E27FC236}">
-                <a16:creationId xmlns:a16="http://schemas.microsoft.com/office/drawing/2014/main" id="{552AF73C-ECF7-4DEF-B457-415467670871}"/>
+                <a16:creationId xmlns:a16="http://schemas.microsoft.com/office/drawing/2014/main" id="{1708E77D-A34B-4D1C-BEFE-496444B4E50D}"/>
               </a:ext>
             </a:extLst>
           </p:cNvPr>
@@ -12858,7 +12860,7 @@
           <p:cNvPr id="11" name="">
             <a:extLst xmlns:a="http://schemas.openxmlformats.org/drawingml/2006/main">
               <a:ext uri="{FF2B5EF4-FFF2-40B4-BE49-F238E27FC236}">
-                <a16:creationId xmlns:a16="http://schemas.microsoft.com/office/drawing/2014/main" id="{A344C9DF-204E-47FD-A30E-C87AE95336D2}"/>
+                <a16:creationId xmlns:a16="http://schemas.microsoft.com/office/drawing/2014/main" id="{2425383A-DC95-4628-9AA8-D6D479CF622C}"/>
               </a:ext>
             </a:extLst>
           </p:cNvPr>
@@ -12926,7 +12928,7 @@
           <p:cNvPr id="12" name="">
             <a:extLst xmlns:a="http://schemas.openxmlformats.org/drawingml/2006/main">
               <a:ext uri="{FF2B5EF4-FFF2-40B4-BE49-F238E27FC236}">
-                <a16:creationId xmlns:a16="http://schemas.microsoft.com/office/drawing/2014/main" id="{64BD1DA8-1B5C-40DF-B769-C9909A80E287}"/>
+                <a16:creationId xmlns:a16="http://schemas.microsoft.com/office/drawing/2014/main" id="{8FBB1DA2-4309-4EB3-A163-AC8E94E306BE}"/>
               </a:ext>
             </a:extLst>
           </p:cNvPr>
@@ -12960,7 +12962,7 @@
           <p:cNvPr id="13" name="">
             <a:extLst xmlns:a="http://schemas.openxmlformats.org/drawingml/2006/main">
               <a:ext uri="{FF2B5EF4-FFF2-40B4-BE49-F238E27FC236}">
-                <a16:creationId xmlns:a16="http://schemas.microsoft.com/office/drawing/2014/main" id="{282BF8C7-B893-4664-B349-C1A091A4EC8E}"/>
+                <a16:creationId xmlns:a16="http://schemas.microsoft.com/office/drawing/2014/main" id="{FE5FB024-F7F9-4E59-A353-B075B2E3E242}"/>
               </a:ext>
             </a:extLst>
           </p:cNvPr>
@@ -13028,7 +13030,7 @@
           <p:cNvPr id="14" name="">
             <a:extLst xmlns:a="http://schemas.openxmlformats.org/drawingml/2006/main">
               <a:ext uri="{FF2B5EF4-FFF2-40B4-BE49-F238E27FC236}">
-                <a16:creationId xmlns:a16="http://schemas.microsoft.com/office/drawing/2014/main" id="{03895E58-E7E9-45D7-AD2D-CA4D4D79AE6F}"/>
+                <a16:creationId xmlns:a16="http://schemas.microsoft.com/office/drawing/2014/main" id="{26027420-2F56-4C2C-8A3F-C590B42819C7}"/>
               </a:ext>
             </a:extLst>
           </p:cNvPr>
@@ -13119,7 +13121,7 @@
           <p:cNvPr id="15" name="">
             <a:extLst xmlns:a="http://schemas.openxmlformats.org/drawingml/2006/main">
               <a:ext uri="{FF2B5EF4-FFF2-40B4-BE49-F238E27FC236}">
-                <a16:creationId xmlns:a16="http://schemas.microsoft.com/office/drawing/2014/main" id="{A016B3D6-8884-4660-AA90-093A8176E565}"/>
+                <a16:creationId xmlns:a16="http://schemas.microsoft.com/office/drawing/2014/main" id="{697BEAF5-4E66-42B4-B4A6-835714486FB6}"/>
               </a:ext>
             </a:extLst>
           </p:cNvPr>
@@ -13187,7 +13189,7 @@
           <p:cNvPr id="16" name="">
             <a:extLst xmlns:a="http://schemas.openxmlformats.org/drawingml/2006/main">
               <a:ext uri="{FF2B5EF4-FFF2-40B4-BE49-F238E27FC236}">
-                <a16:creationId xmlns:a16="http://schemas.microsoft.com/office/drawing/2014/main" id="{134CBC73-EDFE-4CE5-9B1A-1C144B746717}"/>
+                <a16:creationId xmlns:a16="http://schemas.microsoft.com/office/drawing/2014/main" id="{4A91F274-986E-484B-8692-266559539DA4}"/>
               </a:ext>
             </a:extLst>
           </p:cNvPr>
@@ -13221,7 +13223,7 @@
           <p:cNvPr id="17" name="">
             <a:extLst xmlns:a="http://schemas.openxmlformats.org/drawingml/2006/main">
               <a:ext uri="{FF2B5EF4-FFF2-40B4-BE49-F238E27FC236}">
-                <a16:creationId xmlns:a16="http://schemas.microsoft.com/office/drawing/2014/main" id="{406F1986-DF6C-4544-BA0B-6E22D04C0899}"/>
+                <a16:creationId xmlns:a16="http://schemas.microsoft.com/office/drawing/2014/main" id="{48975E7B-62F3-4DD6-9B79-C3B4AA74D3E4}"/>
               </a:ext>
             </a:extLst>
           </p:cNvPr>
@@ -13289,7 +13291,7 @@
           <p:cNvPr id="18" name="">
             <a:extLst xmlns:a="http://schemas.openxmlformats.org/drawingml/2006/main">
               <a:ext uri="{FF2B5EF4-FFF2-40B4-BE49-F238E27FC236}">
-                <a16:creationId xmlns:a16="http://schemas.microsoft.com/office/drawing/2014/main" id="{7F9DBFFA-E9D2-4B70-AB6D-24A4E90DC538}"/>
+                <a16:creationId xmlns:a16="http://schemas.microsoft.com/office/drawing/2014/main" id="{98B1126B-8935-4CFD-889D-163DFB8355D5}"/>
               </a:ext>
             </a:extLst>
           </p:cNvPr>
@@ -13403,7 +13405,7 @@
           <p:cNvPr id="19" name="">
             <a:extLst xmlns:a="http://schemas.openxmlformats.org/drawingml/2006/main">
               <a:ext uri="{FF2B5EF4-FFF2-40B4-BE49-F238E27FC236}">
-                <a16:creationId xmlns:a16="http://schemas.microsoft.com/office/drawing/2014/main" id="{916D213C-3D18-4A32-9B9F-87BEADEFDAAC}"/>
+                <a16:creationId xmlns:a16="http://schemas.microsoft.com/office/drawing/2014/main" id="{7CEBD03E-E788-4563-A24F-B6881EF1E44E}"/>
               </a:ext>
             </a:extLst>
           </p:cNvPr>
@@ -13471,7 +13473,7 @@
           <p:cNvPr id="20" name="">
             <a:extLst xmlns:a="http://schemas.openxmlformats.org/drawingml/2006/main">
               <a:ext uri="{FF2B5EF4-FFF2-40B4-BE49-F238E27FC236}">
-                <a16:creationId xmlns:a16="http://schemas.microsoft.com/office/drawing/2014/main" id="{0B81F30A-34B1-49DE-BF72-80DEE2166B62}"/>
+                <a16:creationId xmlns:a16="http://schemas.microsoft.com/office/drawing/2014/main" id="{C96AB656-19C5-4CB2-B455-F9C0794269DE}"/>
               </a:ext>
             </a:extLst>
           </p:cNvPr>
@@ -13537,7 +13539,7 @@
     </p:spTree>
     <p:extLst>
       <p:ext uri="{BB962C8B-B14F-4D97-AF65-F5344CB8AC3E}">
-        <p14:creationId xmlns:p14="http://schemas.microsoft.com/office/powerpoint/2010/main" val="132741767"/>
+        <p14:creationId xmlns:p14="http://schemas.microsoft.com/office/powerpoint/2010/main" val="430321838"/>
       </p:ext>
     </p:extLst>
   </p:cSld>
@@ -13568,7 +13570,7 @@
           <p:cNvPr id="9" name="">
             <a:extLst xmlns:a="http://schemas.openxmlformats.org/drawingml/2006/main">
               <a:ext uri="{FF2B5EF4-FFF2-40B4-BE49-F238E27FC236}">
-                <a16:creationId xmlns:a16="http://schemas.microsoft.com/office/drawing/2014/main" id="{66348244-F761-4765-AFB4-AF9B7CDA8CFD}"/>
+                <a16:creationId xmlns:a16="http://schemas.microsoft.com/office/drawing/2014/main" id="{A682762F-941F-4045-A8FB-B7CCD719BE75}"/>
               </a:ext>
             </a:extLst>
           </p:cNvPr>
@@ -13636,7 +13638,7 @@
           <p:cNvPr id="2" name="">
             <a:extLst xmlns:a="http://schemas.openxmlformats.org/drawingml/2006/main">
               <a:ext uri="{FF2B5EF4-FFF2-40B4-BE49-F238E27FC236}">
-                <a16:creationId xmlns:a16="http://schemas.microsoft.com/office/drawing/2014/main" id="{A7E35A1C-2EB1-4FF0-B60E-0796B3AAE415}"/>
+                <a16:creationId xmlns:a16="http://schemas.microsoft.com/office/drawing/2014/main" id="{BBB65380-F149-4624-AC4F-A2B2FC433E5F}"/>
               </a:ext>
             </a:extLst>
           </p:cNvPr>
@@ -13704,7 +13706,7 @@
           <p:cNvPr id="3" name="">
             <a:extLst xmlns:a="http://schemas.openxmlformats.org/drawingml/2006/main">
               <a:ext uri="{FF2B5EF4-FFF2-40B4-BE49-F238E27FC236}">
-                <a16:creationId xmlns:a16="http://schemas.microsoft.com/office/drawing/2014/main" id="{49858BE9-4F48-4AD9-89A8-E4E4277F3803}"/>
+                <a16:creationId xmlns:a16="http://schemas.microsoft.com/office/drawing/2014/main" id="{11D7906B-C7A5-4F97-B183-F46ED9459DA8}"/>
               </a:ext>
             </a:extLst>
           </p:cNvPr>
@@ -13734,7 +13736,7 @@
           <p:cNvPr id="4" name="Chart">
             <a:extLst xmlns:a="http://schemas.openxmlformats.org/drawingml/2006/main">
               <a:ext uri="{FF2B5EF4-FFF2-40B4-BE49-F238E27FC236}">
-                <a16:creationId xmlns:a16="http://schemas.microsoft.com/office/drawing/2014/main" id="{ED177BD9-0FBA-40A3-B0D3-81B76F5FC09C}"/>
+                <a16:creationId xmlns:a16="http://schemas.microsoft.com/office/drawing/2014/main" id="{9A3E44F4-D473-4D8A-BE66-050A156AC18B}"/>
               </a:ext>
             </a:extLst>
           </p:cNvPr>
@@ -13747,7 +13749,7 @@
         </p:xfrm>
         <a:graphic xmlns:a="http://schemas.openxmlformats.org/drawingml/2006/main">
           <a:graphicData uri="http://schemas.openxmlformats.org/drawingml/2006/chart">
-            <c:chart xmlns:r="http://schemas.openxmlformats.org/officeDocument/2006/relationships" xmlns:c="http://schemas.openxmlformats.org/drawingml/2006/chart" r:id="R01138b3c6fd34e34"/>
+            <c:chart xmlns:r="http://schemas.openxmlformats.org/officeDocument/2006/relationships" xmlns:c="http://schemas.openxmlformats.org/drawingml/2006/chart" r:id="R5a5c1eec9cf841f8"/>
           </a:graphicData>
         </a:graphic>
       </p:graphicFrame>
@@ -13756,7 +13758,7 @@
           <p:cNvPr id="5" name="">
             <a:extLst xmlns:a="http://schemas.openxmlformats.org/drawingml/2006/main">
               <a:ext uri="{FF2B5EF4-FFF2-40B4-BE49-F238E27FC236}">
-                <a16:creationId xmlns:a16="http://schemas.microsoft.com/office/drawing/2014/main" id="{E7A35A36-86FC-4848-9DCF-23167B9930DE}"/>
+                <a16:creationId xmlns:a16="http://schemas.microsoft.com/office/drawing/2014/main" id="{694CE134-9D9B-481D-8564-FE05A82B2EAC}"/>
               </a:ext>
             </a:extLst>
           </p:cNvPr>
@@ -13766,7 +13768,7 @@
           <p:nvPr/>
         </p:nvPicPr>
         <p:blipFill>
-          <a:blip xmlns:r="http://schemas.openxmlformats.org/officeDocument/2006/relationships" xmlns:a="http://schemas.openxmlformats.org/drawingml/2006/main" r:embed="R804306b309e14e9c"/>
+          <a:blip xmlns:r="http://schemas.openxmlformats.org/officeDocument/2006/relationships" xmlns:a="http://schemas.openxmlformats.org/drawingml/2006/main" r:embed="R0e878c571bfd4c61"/>
           <a:stretch xmlns:a="http://schemas.openxmlformats.org/drawingml/2006/main"/>
         </p:blipFill>
         <p:spPr>
@@ -13784,7 +13786,7 @@
           <p:cNvPr id="6" name="">
             <a:extLst xmlns:a="http://schemas.openxmlformats.org/drawingml/2006/main">
               <a:ext uri="{FF2B5EF4-FFF2-40B4-BE49-F238E27FC236}">
-                <a16:creationId xmlns:a16="http://schemas.microsoft.com/office/drawing/2014/main" id="{E8E4BA2F-82FB-4188-B8D8-4880B394247E}"/>
+                <a16:creationId xmlns:a16="http://schemas.microsoft.com/office/drawing/2014/main" id="{C0312855-1D8F-4260-9F54-C97632045A5A}"/>
               </a:ext>
             </a:extLst>
           </p:cNvPr>
@@ -13852,7 +13854,7 @@
           <p:cNvPr id="7" name="">
             <a:extLst xmlns:a="http://schemas.openxmlformats.org/drawingml/2006/main">
               <a:ext uri="{FF2B5EF4-FFF2-40B4-BE49-F238E27FC236}">
-                <a16:creationId xmlns:a16="http://schemas.microsoft.com/office/drawing/2014/main" id="{424BBA1B-38FE-445D-B60F-9AB913E7AEBD}"/>
+                <a16:creationId xmlns:a16="http://schemas.microsoft.com/office/drawing/2014/main" id="{C31C8B08-457C-4CDD-ABAB-FF5DB773D291}"/>
               </a:ext>
             </a:extLst>
           </p:cNvPr>
@@ -13920,7 +13922,7 @@
           <p:cNvPr id="8" name="">
             <a:extLst xmlns:a="http://schemas.openxmlformats.org/drawingml/2006/main">
               <a:ext uri="{FF2B5EF4-FFF2-40B4-BE49-F238E27FC236}">
-                <a16:creationId xmlns:a16="http://schemas.microsoft.com/office/drawing/2014/main" id="{E9430A58-9BAD-433E-853C-4B155E5B95BE}"/>
+                <a16:creationId xmlns:a16="http://schemas.microsoft.com/office/drawing/2014/main" id="{5B741964-E921-4967-9279-71B7D0991DCA}"/>
               </a:ext>
             </a:extLst>
           </p:cNvPr>
@@ -13986,7 +13988,7 @@
     </p:spTree>
     <p:extLst>
       <p:ext uri="{BB962C8B-B14F-4D97-AF65-F5344CB8AC3E}">
-        <p14:creationId xmlns:p14="http://schemas.microsoft.com/office/powerpoint/2010/main" val="20690562"/>
+        <p14:creationId xmlns:p14="http://schemas.microsoft.com/office/powerpoint/2010/main" val="1138694004"/>
       </p:ext>
     </p:extLst>
   </p:cSld>
@@ -14017,7 +14019,7 @@
           <p:cNvPr id="17" name="">
             <a:extLst xmlns:a="http://schemas.openxmlformats.org/drawingml/2006/main">
               <a:ext uri="{FF2B5EF4-FFF2-40B4-BE49-F238E27FC236}">
-                <a16:creationId xmlns:a16="http://schemas.microsoft.com/office/drawing/2014/main" id="{7CDAC782-6B9F-4B07-A81A-F8EF4817041D}"/>
+                <a16:creationId xmlns:a16="http://schemas.microsoft.com/office/drawing/2014/main" id="{5155421C-7A0E-4C86-BDC1-DA738A0A29FA}"/>
               </a:ext>
             </a:extLst>
           </p:cNvPr>
@@ -14085,7 +14087,7 @@
           <p:cNvPr id="2" name="">
             <a:extLst xmlns:a="http://schemas.openxmlformats.org/drawingml/2006/main">
               <a:ext uri="{FF2B5EF4-FFF2-40B4-BE49-F238E27FC236}">
-                <a16:creationId xmlns:a16="http://schemas.microsoft.com/office/drawing/2014/main" id="{2D8EBF41-2DCD-470E-8F51-8636AA819E41}"/>
+                <a16:creationId xmlns:a16="http://schemas.microsoft.com/office/drawing/2014/main" id="{63C8C707-F65C-4713-9ED8-A52F535CF222}"/>
               </a:ext>
             </a:extLst>
           </p:cNvPr>
@@ -14153,7 +14155,7 @@
           <p:cNvPr id="3" name="">
             <a:extLst xmlns:a="http://schemas.openxmlformats.org/drawingml/2006/main">
               <a:ext uri="{FF2B5EF4-FFF2-40B4-BE49-F238E27FC236}">
-                <a16:creationId xmlns:a16="http://schemas.microsoft.com/office/drawing/2014/main" id="{FCCC502D-98D3-402B-8A91-3A061B9DF91F}"/>
+                <a16:creationId xmlns:a16="http://schemas.microsoft.com/office/drawing/2014/main" id="{386A8866-6F7B-4092-B4B4-9C01058B15CD}"/>
               </a:ext>
             </a:extLst>
           </p:cNvPr>
@@ -14183,7 +14185,7 @@
           <p:cNvPr id="4" name="">
             <a:extLst xmlns:a="http://schemas.openxmlformats.org/drawingml/2006/main">
               <a:ext uri="{FF2B5EF4-FFF2-40B4-BE49-F238E27FC236}">
-                <a16:creationId xmlns:a16="http://schemas.microsoft.com/office/drawing/2014/main" id="{5092DE7E-B45A-435A-8ABC-6E1006C8BAEC}"/>
+                <a16:creationId xmlns:a16="http://schemas.microsoft.com/office/drawing/2014/main" id="{D314E334-71CF-48C2-8CD8-DC6D7A02ECBF}"/>
               </a:ext>
             </a:extLst>
           </p:cNvPr>
@@ -14217,7 +14219,7 @@
           <p:cNvPr id="5" name="">
             <a:extLst xmlns:a="http://schemas.openxmlformats.org/drawingml/2006/main">
               <a:ext uri="{FF2B5EF4-FFF2-40B4-BE49-F238E27FC236}">
-                <a16:creationId xmlns:a16="http://schemas.microsoft.com/office/drawing/2014/main" id="{B50F3DF8-0C6F-4F83-B302-FFA4B049F165}"/>
+                <a16:creationId xmlns:a16="http://schemas.microsoft.com/office/drawing/2014/main" id="{1720EE22-491E-4C24-90BB-234A3FB22553}"/>
               </a:ext>
             </a:extLst>
           </p:cNvPr>
@@ -14285,7 +14287,7 @@
           <p:cNvPr id="6" name="">
             <a:extLst xmlns:a="http://schemas.openxmlformats.org/drawingml/2006/main">
               <a:ext uri="{FF2B5EF4-FFF2-40B4-BE49-F238E27FC236}">
-                <a16:creationId xmlns:a16="http://schemas.microsoft.com/office/drawing/2014/main" id="{7B4FD5E3-5FD1-4066-BCB3-B01271EBE7B0}"/>
+                <a16:creationId xmlns:a16="http://schemas.microsoft.com/office/drawing/2014/main" id="{FC66A722-4E4B-4CC5-A271-55E9A1B7A3A0}"/>
               </a:ext>
             </a:extLst>
           </p:cNvPr>
@@ -14353,7 +14355,7 @@
           <p:cNvPr id="7" name="">
             <a:extLst xmlns:a="http://schemas.openxmlformats.org/drawingml/2006/main">
               <a:ext uri="{FF2B5EF4-FFF2-40B4-BE49-F238E27FC236}">
-                <a16:creationId xmlns:a16="http://schemas.microsoft.com/office/drawing/2014/main" id="{7A1C0374-364C-45E1-83D9-FF71E6D549F6}"/>
+                <a16:creationId xmlns:a16="http://schemas.microsoft.com/office/drawing/2014/main" id="{E98963FB-B054-487E-A8AB-1E0304E2DE53}"/>
               </a:ext>
             </a:extLst>
           </p:cNvPr>
@@ -14387,7 +14389,7 @@
           <p:cNvPr id="8" name="">
             <a:extLst xmlns:a="http://schemas.openxmlformats.org/drawingml/2006/main">
               <a:ext uri="{FF2B5EF4-FFF2-40B4-BE49-F238E27FC236}">
-                <a16:creationId xmlns:a16="http://schemas.microsoft.com/office/drawing/2014/main" id="{4D3F03D5-D994-4613-AD18-0D5E7F350693}"/>
+                <a16:creationId xmlns:a16="http://schemas.microsoft.com/office/drawing/2014/main" id="{36270813-2B5C-4D3F-AE6A-EACFB6A14592}"/>
               </a:ext>
             </a:extLst>
           </p:cNvPr>
@@ -14455,7 +14457,7 @@
           <p:cNvPr id="9" name="">
             <a:extLst xmlns:a="http://schemas.openxmlformats.org/drawingml/2006/main">
               <a:ext uri="{FF2B5EF4-FFF2-40B4-BE49-F238E27FC236}">
-                <a16:creationId xmlns:a16="http://schemas.microsoft.com/office/drawing/2014/main" id="{6EC6A147-49D0-49BA-AA71-E9C9A89B11B8}"/>
+                <a16:creationId xmlns:a16="http://schemas.microsoft.com/office/drawing/2014/main" id="{74DB95A7-1133-4FB7-B7ED-48BFD565FC63}"/>
               </a:ext>
             </a:extLst>
           </p:cNvPr>
@@ -14523,7 +14525,7 @@
           <p:cNvPr id="10" name="">
             <a:extLst xmlns:a="http://schemas.openxmlformats.org/drawingml/2006/main">
               <a:ext uri="{FF2B5EF4-FFF2-40B4-BE49-F238E27FC236}">
-                <a16:creationId xmlns:a16="http://schemas.microsoft.com/office/drawing/2014/main" id="{65330EAE-AB65-4AD9-8E4D-988A7CE0DBD2}"/>
+                <a16:creationId xmlns:a16="http://schemas.microsoft.com/office/drawing/2014/main" id="{ED308E83-7892-41ED-9352-9B72E03BF0F1}"/>
               </a:ext>
             </a:extLst>
           </p:cNvPr>
@@ -14557,7 +14559,7 @@
           <p:cNvPr id="11" name="">
             <a:extLst xmlns:a="http://schemas.openxmlformats.org/drawingml/2006/main">
               <a:ext uri="{FF2B5EF4-FFF2-40B4-BE49-F238E27FC236}">
-                <a16:creationId xmlns:a16="http://schemas.microsoft.com/office/drawing/2014/main" id="{33ACC06D-FE63-4496-82E9-36EC9BC45262}"/>
+                <a16:creationId xmlns:a16="http://schemas.microsoft.com/office/drawing/2014/main" id="{D4BCF933-B69E-4A6E-A601-759614E63D98}"/>
               </a:ext>
             </a:extLst>
           </p:cNvPr>
@@ -14625,7 +14627,7 @@
           <p:cNvPr id="12" name="">
             <a:extLst xmlns:a="http://schemas.openxmlformats.org/drawingml/2006/main">
               <a:ext uri="{FF2B5EF4-FFF2-40B4-BE49-F238E27FC236}">
-                <a16:creationId xmlns:a16="http://schemas.microsoft.com/office/drawing/2014/main" id="{2C67B6D8-D3C7-4084-A7E5-F29491697385}"/>
+                <a16:creationId xmlns:a16="http://schemas.microsoft.com/office/drawing/2014/main" id="{3C59F96D-3D06-4AD3-A7ED-31DB3327CD60}"/>
               </a:ext>
             </a:extLst>
           </p:cNvPr>
@@ -14716,7 +14718,7 @@
           <p:cNvPr id="13" name="">
             <a:extLst xmlns:a="http://schemas.openxmlformats.org/drawingml/2006/main">
               <a:ext uri="{FF2B5EF4-FFF2-40B4-BE49-F238E27FC236}">
-                <a16:creationId xmlns:a16="http://schemas.microsoft.com/office/drawing/2014/main" id="{61CF6AB8-A837-4242-8F81-E1308A0D0B56}"/>
+                <a16:creationId xmlns:a16="http://schemas.microsoft.com/office/drawing/2014/main" id="{78C5DCE4-9F55-4546-9EEC-6A7593A2FE19}"/>
               </a:ext>
             </a:extLst>
           </p:cNvPr>
@@ -14784,7 +14786,7 @@
           <p:cNvPr id="14" name="">
             <a:extLst xmlns:a="http://schemas.openxmlformats.org/drawingml/2006/main">
               <a:ext uri="{FF2B5EF4-FFF2-40B4-BE49-F238E27FC236}">
-                <a16:creationId xmlns:a16="http://schemas.microsoft.com/office/drawing/2014/main" id="{35FFF33C-AC47-46D0-8E3D-0C9F944B4DB8}"/>
+                <a16:creationId xmlns:a16="http://schemas.microsoft.com/office/drawing/2014/main" id="{F2319E5C-4077-4FC1-ABC0-DA2CEC39F1FC}"/>
               </a:ext>
             </a:extLst>
           </p:cNvPr>
@@ -14852,7 +14854,7 @@
           <p:cNvPr id="15" name="">
             <a:extLst xmlns:a="http://schemas.openxmlformats.org/drawingml/2006/main">
               <a:ext uri="{FF2B5EF4-FFF2-40B4-BE49-F238E27FC236}">
-                <a16:creationId xmlns:a16="http://schemas.microsoft.com/office/drawing/2014/main" id="{1DADBA5B-A03B-4391-87E2-948198EB446C}"/>
+                <a16:creationId xmlns:a16="http://schemas.microsoft.com/office/drawing/2014/main" id="{A1CA66B9-7CB3-4887-BD08-8BA7F81A97DB}"/>
               </a:ext>
             </a:extLst>
           </p:cNvPr>
@@ -14920,7 +14922,7 @@
           <p:cNvPr id="16" name="">
             <a:extLst xmlns:a="http://schemas.openxmlformats.org/drawingml/2006/main">
               <a:ext uri="{FF2B5EF4-FFF2-40B4-BE49-F238E27FC236}">
-                <a16:creationId xmlns:a16="http://schemas.microsoft.com/office/drawing/2014/main" id="{525B4696-05C3-4553-86F7-9C7330994ED4}"/>
+                <a16:creationId xmlns:a16="http://schemas.microsoft.com/office/drawing/2014/main" id="{6FE445E6-65FC-43EB-ADB0-D7ECC08E2F6D}"/>
               </a:ext>
             </a:extLst>
           </p:cNvPr>
@@ -14986,7 +14988,7 @@
     </p:spTree>
     <p:extLst>
       <p:ext uri="{BB962C8B-B14F-4D97-AF65-F5344CB8AC3E}">
-        <p14:creationId xmlns:p14="http://schemas.microsoft.com/office/powerpoint/2010/main" val="549328972"/>
+        <p14:creationId xmlns:p14="http://schemas.microsoft.com/office/powerpoint/2010/main" val="2032410949"/>
       </p:ext>
     </p:extLst>
   </p:cSld>
@@ -15017,7 +15019,7 @@
           <p:cNvPr id="9" name="">
             <a:extLst xmlns:a="http://schemas.openxmlformats.org/drawingml/2006/main">
               <a:ext uri="{FF2B5EF4-FFF2-40B4-BE49-F238E27FC236}">
-                <a16:creationId xmlns:a16="http://schemas.microsoft.com/office/drawing/2014/main" id="{34202990-379F-4BCC-A8D6-5FDB45677E45}"/>
+                <a16:creationId xmlns:a16="http://schemas.microsoft.com/office/drawing/2014/main" id="{4E227505-7ADE-47D3-9B24-1CFE1C8A813F}"/>
               </a:ext>
             </a:extLst>
           </p:cNvPr>
@@ -15085,7 +15087,7 @@
           <p:cNvPr id="2" name="">
             <a:extLst xmlns:a="http://schemas.openxmlformats.org/drawingml/2006/main">
               <a:ext uri="{FF2B5EF4-FFF2-40B4-BE49-F238E27FC236}">
-                <a16:creationId xmlns:a16="http://schemas.microsoft.com/office/drawing/2014/main" id="{6DCD1AD9-3E05-4857-ABEC-2461744435D8}"/>
+                <a16:creationId xmlns:a16="http://schemas.microsoft.com/office/drawing/2014/main" id="{C8A158AF-3A2E-422F-B271-E45B30B63D91}"/>
               </a:ext>
             </a:extLst>
           </p:cNvPr>
@@ -15153,7 +15155,7 @@
           <p:cNvPr id="3" name="">
             <a:extLst xmlns:a="http://schemas.openxmlformats.org/drawingml/2006/main">
               <a:ext uri="{FF2B5EF4-FFF2-40B4-BE49-F238E27FC236}">
-                <a16:creationId xmlns:a16="http://schemas.microsoft.com/office/drawing/2014/main" id="{FD37B2F1-9F14-4ABF-85D6-95E7CC7812B4}"/>
+                <a16:creationId xmlns:a16="http://schemas.microsoft.com/office/drawing/2014/main" id="{988A580B-98FD-4824-BEE7-E038554BC24E}"/>
               </a:ext>
             </a:extLst>
           </p:cNvPr>
@@ -15183,7 +15185,7 @@
           <p:cNvPr id="4" name="Chart">
             <a:extLst xmlns:a="http://schemas.openxmlformats.org/drawingml/2006/main">
               <a:ext uri="{FF2B5EF4-FFF2-40B4-BE49-F238E27FC236}">
-                <a16:creationId xmlns:a16="http://schemas.microsoft.com/office/drawing/2014/main" id="{EA704F3B-D23B-41F6-8F81-135B7C0F30BB}"/>
+                <a16:creationId xmlns:a16="http://schemas.microsoft.com/office/drawing/2014/main" id="{377E2053-75D7-4E0C-8B17-767DC5333348}"/>
               </a:ext>
             </a:extLst>
           </p:cNvPr>
@@ -15196,7 +15198,7 @@
         </p:xfrm>
         <a:graphic xmlns:a="http://schemas.openxmlformats.org/drawingml/2006/main">
           <a:graphicData uri="http://schemas.openxmlformats.org/drawingml/2006/chart">
-            <c:chart xmlns:r="http://schemas.openxmlformats.org/officeDocument/2006/relationships" xmlns:c="http://schemas.openxmlformats.org/drawingml/2006/chart" r:id="R054bd1a3e6204ce3"/>
+            <c:chart xmlns:r="http://schemas.openxmlformats.org/officeDocument/2006/relationships" xmlns:c="http://schemas.openxmlformats.org/drawingml/2006/chart" r:id="R9820521f18e943cf"/>
           </a:graphicData>
         </a:graphic>
       </p:graphicFrame>
@@ -15205,7 +15207,7 @@
           <p:cNvPr id="5" name="">
             <a:extLst xmlns:a="http://schemas.openxmlformats.org/drawingml/2006/main">
               <a:ext uri="{FF2B5EF4-FFF2-40B4-BE49-F238E27FC236}">
-                <a16:creationId xmlns:a16="http://schemas.microsoft.com/office/drawing/2014/main" id="{72B1F9FE-DBBA-4882-9711-0966B7AB1963}"/>
+                <a16:creationId xmlns:a16="http://schemas.microsoft.com/office/drawing/2014/main" id="{9E99A7E0-33C1-4A2C-BB10-1C006735BA60}"/>
               </a:ext>
             </a:extLst>
           </p:cNvPr>
@@ -15273,7 +15275,7 @@
           <p:cNvPr id="6" name="">
             <a:extLst xmlns:a="http://schemas.openxmlformats.org/drawingml/2006/main">
               <a:ext uri="{FF2B5EF4-FFF2-40B4-BE49-F238E27FC236}">
-                <a16:creationId xmlns:a16="http://schemas.microsoft.com/office/drawing/2014/main" id="{88CD21B8-6ED0-4072-AEC8-AC9E0DC604B5}"/>
+                <a16:creationId xmlns:a16="http://schemas.microsoft.com/office/drawing/2014/main" id="{2C15705A-C35F-4180-9E43-F6646A68AE4E}"/>
               </a:ext>
             </a:extLst>
           </p:cNvPr>
@@ -15443,7 +15445,7 @@
           <p:cNvPr id="7" name="">
             <a:extLst xmlns:a="http://schemas.openxmlformats.org/drawingml/2006/main">
               <a:ext uri="{FF2B5EF4-FFF2-40B4-BE49-F238E27FC236}">
-                <a16:creationId xmlns:a16="http://schemas.microsoft.com/office/drawing/2014/main" id="{6D25E370-0071-4C77-8725-DB6013480F10}"/>
+                <a16:creationId xmlns:a16="http://schemas.microsoft.com/office/drawing/2014/main" id="{D0EDC18A-E10C-4E56-9F91-810C7CD6EED2}"/>
               </a:ext>
             </a:extLst>
           </p:cNvPr>
@@ -15511,7 +15513,7 @@
           <p:cNvPr id="8" name="">
             <a:extLst xmlns:a="http://schemas.openxmlformats.org/drawingml/2006/main">
               <a:ext uri="{FF2B5EF4-FFF2-40B4-BE49-F238E27FC236}">
-                <a16:creationId xmlns:a16="http://schemas.microsoft.com/office/drawing/2014/main" id="{DAF62A48-7DF3-40C6-AAF0-44801FD26844}"/>
+                <a16:creationId xmlns:a16="http://schemas.microsoft.com/office/drawing/2014/main" id="{84F9CDAF-810D-4B9C-ABB4-35A28E67AEC9}"/>
               </a:ext>
             </a:extLst>
           </p:cNvPr>
@@ -15577,7 +15579,7 @@
     </p:spTree>
     <p:extLst>
       <p:ext uri="{BB962C8B-B14F-4D97-AF65-F5344CB8AC3E}">
-        <p14:creationId xmlns:p14="http://schemas.microsoft.com/office/powerpoint/2010/main" val="779658783"/>
+        <p14:creationId xmlns:p14="http://schemas.microsoft.com/office/powerpoint/2010/main" val="751075116"/>
       </p:ext>
     </p:extLst>
   </p:cSld>
@@ -15608,7 +15610,7 @@
           <p:cNvPr id="11" name="">
             <a:extLst xmlns:a="http://schemas.openxmlformats.org/drawingml/2006/main">
               <a:ext uri="{FF2B5EF4-FFF2-40B4-BE49-F238E27FC236}">
-                <a16:creationId xmlns:a16="http://schemas.microsoft.com/office/drawing/2014/main" id="{23A2E401-A3D7-4339-A333-154C11AD2052}"/>
+                <a16:creationId xmlns:a16="http://schemas.microsoft.com/office/drawing/2014/main" id="{0CAA6CCA-1FCA-4C10-8B0A-EB313AA7F96D}"/>
               </a:ext>
             </a:extLst>
           </p:cNvPr>
@@ -15676,7 +15678,7 @@
           <p:cNvPr id="2" name="">
             <a:extLst xmlns:a="http://schemas.openxmlformats.org/drawingml/2006/main">
               <a:ext uri="{FF2B5EF4-FFF2-40B4-BE49-F238E27FC236}">
-                <a16:creationId xmlns:a16="http://schemas.microsoft.com/office/drawing/2014/main" id="{D4DBD10F-6E48-45F1-BB28-A94BF5F983BD}"/>
+                <a16:creationId xmlns:a16="http://schemas.microsoft.com/office/drawing/2014/main" id="{927EA09B-0733-4919-9754-A07394510F9B}"/>
               </a:ext>
             </a:extLst>
           </p:cNvPr>
@@ -15744,7 +15746,7 @@
           <p:cNvPr id="3" name="">
             <a:extLst xmlns:a="http://schemas.openxmlformats.org/drawingml/2006/main">
               <a:ext uri="{FF2B5EF4-FFF2-40B4-BE49-F238E27FC236}">
-                <a16:creationId xmlns:a16="http://schemas.microsoft.com/office/drawing/2014/main" id="{61EF82BA-2357-44F5-A18F-DC56A5A29334}"/>
+                <a16:creationId xmlns:a16="http://schemas.microsoft.com/office/drawing/2014/main" id="{FDE1D16C-CB11-4CEC-A9B0-36DE448E429A}"/>
               </a:ext>
             </a:extLst>
           </p:cNvPr>
@@ -15774,7 +15776,7 @@
           <p:cNvPr id="4" name="">
             <a:extLst xmlns:a="http://schemas.openxmlformats.org/drawingml/2006/main">
               <a:ext uri="{FF2B5EF4-FFF2-40B4-BE49-F238E27FC236}">
-                <a16:creationId xmlns:a16="http://schemas.microsoft.com/office/drawing/2014/main" id="{BE85D47E-D5E2-4C99-956B-D9AF545D3756}"/>
+                <a16:creationId xmlns:a16="http://schemas.microsoft.com/office/drawing/2014/main" id="{7E651D9B-9814-4747-87AF-5349AAFC4A18}"/>
               </a:ext>
             </a:extLst>
           </p:cNvPr>
@@ -16233,7 +16235,7 @@
           <p:cNvPr id="5" name="">
             <a:extLst xmlns:a="http://schemas.openxmlformats.org/drawingml/2006/main">
               <a:ext uri="{FF2B5EF4-FFF2-40B4-BE49-F238E27FC236}">
-                <a16:creationId xmlns:a16="http://schemas.microsoft.com/office/drawing/2014/main" id="{2258DBED-A9CB-425B-9B4B-37C6E42DBD52}"/>
+                <a16:creationId xmlns:a16="http://schemas.microsoft.com/office/drawing/2014/main" id="{1A267881-42CE-4271-BD02-7633F29842FE}"/>
               </a:ext>
             </a:extLst>
           </p:cNvPr>
@@ -16301,7 +16303,7 @@
           <p:cNvPr id="6" name="">
             <a:extLst xmlns:a="http://schemas.openxmlformats.org/drawingml/2006/main">
               <a:ext uri="{FF2B5EF4-FFF2-40B4-BE49-F238E27FC236}">
-                <a16:creationId xmlns:a16="http://schemas.microsoft.com/office/drawing/2014/main" id="{D53BC13E-1B67-4C1E-960B-8240B319C614}"/>
+                <a16:creationId xmlns:a16="http://schemas.microsoft.com/office/drawing/2014/main" id="{E7F8A707-E103-470A-BCA4-450D336075C4}"/>
               </a:ext>
             </a:extLst>
           </p:cNvPr>
@@ -16443,7 +16445,7 @@
           <p:cNvPr id="7" name="">
             <a:extLst xmlns:a="http://schemas.openxmlformats.org/drawingml/2006/main">
               <a:ext uri="{FF2B5EF4-FFF2-40B4-BE49-F238E27FC236}">
-                <a16:creationId xmlns:a16="http://schemas.microsoft.com/office/drawing/2014/main" id="{DFE10861-562E-4F1B-9A41-DE175D83A5A8}"/>
+                <a16:creationId xmlns:a16="http://schemas.microsoft.com/office/drawing/2014/main" id="{4DE12E08-C7FE-48F1-B995-263AD8E82249}"/>
               </a:ext>
             </a:extLst>
           </p:cNvPr>
@@ -16511,7 +16513,7 @@
           <p:cNvPr id="8" name="">
             <a:extLst xmlns:a="http://schemas.openxmlformats.org/drawingml/2006/main">
               <a:ext uri="{FF2B5EF4-FFF2-40B4-BE49-F238E27FC236}">
-                <a16:creationId xmlns:a16="http://schemas.microsoft.com/office/drawing/2014/main" id="{DEFDC434-295F-4568-88A2-983FDB9A13C1}"/>
+                <a16:creationId xmlns:a16="http://schemas.microsoft.com/office/drawing/2014/main" id="{4EF21625-7BF2-4D73-A06A-F0F81ACD308F}"/>
               </a:ext>
             </a:extLst>
           </p:cNvPr>
@@ -16602,7 +16604,7 @@
           <p:cNvPr id="9" name="">
             <a:extLst xmlns:a="http://schemas.openxmlformats.org/drawingml/2006/main">
               <a:ext uri="{FF2B5EF4-FFF2-40B4-BE49-F238E27FC236}">
-                <a16:creationId xmlns:a16="http://schemas.microsoft.com/office/drawing/2014/main" id="{B58900CF-650A-471A-84FD-1D22DBFEE6EF}"/>
+                <a16:creationId xmlns:a16="http://schemas.microsoft.com/office/drawing/2014/main" id="{B743B4E4-B648-4D08-B57E-94F07389FE22}"/>
               </a:ext>
             </a:extLst>
           </p:cNvPr>
@@ -16670,7 +16672,7 @@
           <p:cNvPr id="10" name="">
             <a:extLst xmlns:a="http://schemas.openxmlformats.org/drawingml/2006/main">
               <a:ext uri="{FF2B5EF4-FFF2-40B4-BE49-F238E27FC236}">
-                <a16:creationId xmlns:a16="http://schemas.microsoft.com/office/drawing/2014/main" id="{EF6B01CB-3F95-4CFF-AD50-807B84855FAD}"/>
+                <a16:creationId xmlns:a16="http://schemas.microsoft.com/office/drawing/2014/main" id="{32F3F524-8194-42D9-9082-6B9E1AD2A43E}"/>
               </a:ext>
             </a:extLst>
           </p:cNvPr>
@@ -16736,7 +16738,7 @@
     </p:spTree>
     <p:extLst>
       <p:ext uri="{BB962C8B-B14F-4D97-AF65-F5344CB8AC3E}">
-        <p14:creationId xmlns:p14="http://schemas.microsoft.com/office/powerpoint/2010/main" val="318843963"/>
+        <p14:creationId xmlns:p14="http://schemas.microsoft.com/office/powerpoint/2010/main" val="821092553"/>
       </p:ext>
     </p:extLst>
   </p:cSld>
@@ -16767,7 +16769,7 @@
           <p:cNvPr id="9" name="">
             <a:extLst xmlns:a="http://schemas.openxmlformats.org/drawingml/2006/main">
               <a:ext uri="{FF2B5EF4-FFF2-40B4-BE49-F238E27FC236}">
-                <a16:creationId xmlns:a16="http://schemas.microsoft.com/office/drawing/2014/main" id="{47B9E668-8AC3-479A-A2A8-2AA0A7088D0B}"/>
+                <a16:creationId xmlns:a16="http://schemas.microsoft.com/office/drawing/2014/main" id="{27C9C7C5-272C-42D3-BA81-EE9CC2EF12EA}"/>
               </a:ext>
             </a:extLst>
           </p:cNvPr>
@@ -16835,7 +16837,7 @@
           <p:cNvPr id="2" name="">
             <a:extLst xmlns:a="http://schemas.openxmlformats.org/drawingml/2006/main">
               <a:ext uri="{FF2B5EF4-FFF2-40B4-BE49-F238E27FC236}">
-                <a16:creationId xmlns:a16="http://schemas.microsoft.com/office/drawing/2014/main" id="{23E6CC4E-6789-43B6-A4FE-77457324BB84}"/>
+                <a16:creationId xmlns:a16="http://schemas.microsoft.com/office/drawing/2014/main" id="{CC197187-B747-4035-9069-4D6E86C4911A}"/>
               </a:ext>
             </a:extLst>
           </p:cNvPr>
@@ -16903,7 +16905,7 @@
           <p:cNvPr id="3" name="">
             <a:extLst xmlns:a="http://schemas.openxmlformats.org/drawingml/2006/main">
               <a:ext uri="{FF2B5EF4-FFF2-40B4-BE49-F238E27FC236}">
-                <a16:creationId xmlns:a16="http://schemas.microsoft.com/office/drawing/2014/main" id="{3F326CBD-0ACE-4D43-905B-DD484BA45105}"/>
+                <a16:creationId xmlns:a16="http://schemas.microsoft.com/office/drawing/2014/main" id="{6B0A3C5F-9FEE-40C1-8EA2-5F0875276803}"/>
               </a:ext>
             </a:extLst>
           </p:cNvPr>
@@ -16933,7 +16935,7 @@
           <p:cNvPr id="4" name="">
             <a:extLst xmlns:a="http://schemas.openxmlformats.org/drawingml/2006/main">
               <a:ext uri="{FF2B5EF4-FFF2-40B4-BE49-F238E27FC236}">
-                <a16:creationId xmlns:a16="http://schemas.microsoft.com/office/drawing/2014/main" id="{B33E1DF5-2EE7-45D1-8C88-2355C42840D8}"/>
+                <a16:creationId xmlns:a16="http://schemas.microsoft.com/office/drawing/2014/main" id="{3E21DBF4-55AD-41E0-BA4C-6AA8A5AA92FF}"/>
               </a:ext>
             </a:extLst>
           </p:cNvPr>
@@ -17389,7 +17391,7 @@
           <p:cNvPr id="5" name="">
             <a:extLst xmlns:a="http://schemas.openxmlformats.org/drawingml/2006/main">
               <a:ext uri="{FF2B5EF4-FFF2-40B4-BE49-F238E27FC236}">
-                <a16:creationId xmlns:a16="http://schemas.microsoft.com/office/drawing/2014/main" id="{B5A6A042-98F5-4B9B-A375-39D7EA5FB7E8}"/>
+                <a16:creationId xmlns:a16="http://schemas.microsoft.com/office/drawing/2014/main" id="{7C202AAB-6FD9-463E-BE18-462C6A3C5C62}"/>
               </a:ext>
             </a:extLst>
           </p:cNvPr>
@@ -17457,7 +17459,7 @@
           <p:cNvPr id="6" name="">
             <a:extLst xmlns:a="http://schemas.openxmlformats.org/drawingml/2006/main">
               <a:ext uri="{FF2B5EF4-FFF2-40B4-BE49-F238E27FC236}">
-                <a16:creationId xmlns:a16="http://schemas.microsoft.com/office/drawing/2014/main" id="{1EE70022-C9CC-4DC8-B043-384FB0CC6240}"/>
+                <a16:creationId xmlns:a16="http://schemas.microsoft.com/office/drawing/2014/main" id="{4F33218A-43EF-4895-B414-16BEB68825AB}"/>
               </a:ext>
             </a:extLst>
           </p:cNvPr>
@@ -17548,7 +17550,7 @@
           <p:cNvPr id="7" name="">
             <a:extLst xmlns:a="http://schemas.openxmlformats.org/drawingml/2006/main">
               <a:ext uri="{FF2B5EF4-FFF2-40B4-BE49-F238E27FC236}">
-                <a16:creationId xmlns:a16="http://schemas.microsoft.com/office/drawing/2014/main" id="{08003DAF-79F2-4CDE-8E96-A9163E92EA12}"/>
+                <a16:creationId xmlns:a16="http://schemas.microsoft.com/office/drawing/2014/main" id="{01E2C182-6BDF-4891-8C83-58C61509C6BB}"/>
               </a:ext>
             </a:extLst>
           </p:cNvPr>
@@ -17639,7 +17641,7 @@
           <p:cNvPr id="8" name="">
             <a:extLst xmlns:a="http://schemas.openxmlformats.org/drawingml/2006/main">
               <a:ext uri="{FF2B5EF4-FFF2-40B4-BE49-F238E27FC236}">
-                <a16:creationId xmlns:a16="http://schemas.microsoft.com/office/drawing/2014/main" id="{E45FCC09-F5C1-4560-8C56-23FB365579CF}"/>
+                <a16:creationId xmlns:a16="http://schemas.microsoft.com/office/drawing/2014/main" id="{AAC8EA0A-4B3E-423D-A413-A16153ED12EB}"/>
               </a:ext>
             </a:extLst>
           </p:cNvPr>
@@ -17705,7 +17707,7 @@
     </p:spTree>
     <p:extLst>
       <p:ext uri="{BB962C8B-B14F-4D97-AF65-F5344CB8AC3E}">
-        <p14:creationId xmlns:p14="http://schemas.microsoft.com/office/powerpoint/2010/main" val="850230047"/>
+        <p14:creationId xmlns:p14="http://schemas.microsoft.com/office/powerpoint/2010/main" val="2114113987"/>
       </p:ext>
     </p:extLst>
   </p:cSld>

</xml_diff>